<commit_message>
Deck: blank template slide, larger typography (125% root), regen PPTX
Made-with: Cursor
</commit_message>
<xml_diff>
--- a/exports/VibeCoding_Presentation.pptx
+++ b/exports/VibeCoding_Presentation.pptx
@@ -29,6 +29,7 @@
     <p:sldId id="277" r:id="rId28"/>
     <p:sldId id="278" r:id="rId29"/>
     <p:sldId id="279" r:id="rId30"/>
+    <p:sldId id="280" r:id="rId31"/>
   </p:sldIdLst>
   <p:sldSz cx="12191695" cy="6858000" type="screen4x3"/>
   <p:notesSz cx="6858000" cy="9144000"/>
@@ -3786,6 +3787,48 @@
       <p:pic>
         <p:nvPicPr>
           <p:cNvPr id="2" name="Picture 1" descr="slide_24.png"/>
+          <p:cNvPicPr>
+            <a:picLocks noChangeAspect="1"/>
+          </p:cNvPicPr>
+          <p:nvPr/>
+        </p:nvPicPr>
+        <p:blipFill>
+          <a:blip r:embed="rId2"/>
+          <a:stretch>
+            <a:fillRect/>
+          </a:stretch>
+        </p:blipFill>
+        <p:spPr>
+          <a:xfrm>
+            <a:off x="0" y="0"/>
+            <a:ext cx="12191695" cy="6858000"/>
+          </a:xfrm>
+          <a:prstGeom prst="rect">
+            <a:avLst/>
+          </a:prstGeom>
+        </p:spPr>
+      </p:pic>
+    </p:spTree>
+  </p:cSld>
+  <p:clrMapOvr>
+    <a:masterClrMapping/>
+  </p:clrMapOvr>
+</p:sld>
+</file>
+
+<file path=ppt/slides/slide25.xml><?xml version="1.0" encoding="utf-8"?>
+<p:sld xmlns:a="http://schemas.openxmlformats.org/drawingml/2006/main" xmlns:p="http://schemas.openxmlformats.org/presentationml/2006/main" xmlns:r="http://schemas.openxmlformats.org/officeDocument/2006/relationships">
+  <p:cSld>
+    <p:spTree>
+      <p:nvGrpSpPr>
+        <p:cNvPr id="1" name=""/>
+        <p:cNvGrpSpPr/>
+        <p:nvPr/>
+      </p:nvGrpSpPr>
+      <p:grpSpPr/>
+      <p:pic>
+        <p:nvPicPr>
+          <p:cNvPr id="2" name="Picture 1" descr="slide_25.png"/>
           <p:cNvPicPr>
             <a:picLocks noChangeAspect="1"/>
           </p:cNvPicPr>

</xml_diff>

<commit_message>
Deck: remove h2 red underline; docs for sharing + screen-record prompts; regen PPTX
Made-with: Cursor
</commit_message>
<xml_diff>
--- a/exports/VibeCoding_Presentation.pptx
+++ b/exports/VibeCoding_Presentation.pptx
@@ -4,34 +4,38 @@
   <p:sldMasterIdLst>
     <p:sldMasterId id="2147483648" r:id="rId1"/>
   </p:sldMasterIdLst>
+  <p:notesMasterIdLst>
+    <p:notesMasterId r:id="rId28"/>
+  </p:notesMasterIdLst>
   <p:sldIdLst>
-    <p:sldId id="256" r:id="rId7"/>
-    <p:sldId id="257" r:id="rId8"/>
-    <p:sldId id="258" r:id="rId9"/>
-    <p:sldId id="259" r:id="rId10"/>
-    <p:sldId id="260" r:id="rId11"/>
-    <p:sldId id="261" r:id="rId12"/>
-    <p:sldId id="262" r:id="rId13"/>
-    <p:sldId id="263" r:id="rId14"/>
-    <p:sldId id="264" r:id="rId15"/>
-    <p:sldId id="265" r:id="rId16"/>
-    <p:sldId id="266" r:id="rId17"/>
-    <p:sldId id="267" r:id="rId18"/>
-    <p:sldId id="268" r:id="rId19"/>
-    <p:sldId id="269" r:id="rId20"/>
-    <p:sldId id="270" r:id="rId21"/>
-    <p:sldId id="271" r:id="rId22"/>
-    <p:sldId id="272" r:id="rId23"/>
-    <p:sldId id="273" r:id="rId24"/>
-    <p:sldId id="274" r:id="rId25"/>
-    <p:sldId id="275" r:id="rId26"/>
-    <p:sldId id="276" r:id="rId27"/>
-    <p:sldId id="277" r:id="rId28"/>
-    <p:sldId id="278" r:id="rId29"/>
-    <p:sldId id="279" r:id="rId30"/>
-    <p:sldId id="280" r:id="rId31"/>
+    <p:sldId id="256" r:id="rId2"/>
+    <p:sldId id="257" r:id="rId3"/>
+    <p:sldId id="2147472835" r:id="rId4"/>
+    <p:sldId id="258" r:id="rId5"/>
+    <p:sldId id="259" r:id="rId6"/>
+    <p:sldId id="260" r:id="rId7"/>
+    <p:sldId id="261" r:id="rId8"/>
+    <p:sldId id="262" r:id="rId9"/>
+    <p:sldId id="263" r:id="rId10"/>
+    <p:sldId id="264" r:id="rId11"/>
+    <p:sldId id="265" r:id="rId12"/>
+    <p:sldId id="266" r:id="rId13"/>
+    <p:sldId id="267" r:id="rId14"/>
+    <p:sldId id="268" r:id="rId15"/>
+    <p:sldId id="269" r:id="rId16"/>
+    <p:sldId id="270" r:id="rId17"/>
+    <p:sldId id="271" r:id="rId18"/>
+    <p:sldId id="272" r:id="rId19"/>
+    <p:sldId id="273" r:id="rId20"/>
+    <p:sldId id="274" r:id="rId21"/>
+    <p:sldId id="275" r:id="rId22"/>
+    <p:sldId id="276" r:id="rId23"/>
+    <p:sldId id="277" r:id="rId24"/>
+    <p:sldId id="278" r:id="rId25"/>
+    <p:sldId id="279" r:id="rId26"/>
+    <p:sldId id="280" r:id="rId27"/>
   </p:sldIdLst>
-  <p:sldSz cx="12191695" cy="6858000" type="screen4x3"/>
+  <p:sldSz cx="12192000" cy="6858000"/>
   <p:notesSz cx="6858000" cy="9144000"/>
   <p:defaultTextStyle>
     <a:defPPr>
@@ -128,7 +132,519 @@
       </a:defRPr>
     </a:lvl9pPr>
   </p:defaultTextStyle>
+  <p:extLst>
+    <p:ext uri="{EFAFB233-063F-42B5-8137-9DF3F51BA10A}">
+      <p15:sldGuideLst xmlns:p15="http://schemas.microsoft.com/office/powerpoint/2012/main">
+        <p15:guide id="1" orient="horz" pos="2160">
+          <p15:clr>
+            <a:srgbClr val="A4A3A4"/>
+          </p15:clr>
+        </p15:guide>
+        <p15:guide id="2" pos="2880">
+          <p15:clr>
+            <a:srgbClr val="A4A3A4"/>
+          </p15:clr>
+        </p15:guide>
+      </p15:sldGuideLst>
+    </p:ext>
+  </p:extLst>
 </p:presentation>
+</file>
+
+<file path=ppt/notesMasters/notesMaster1.xml><?xml version="1.0" encoding="utf-8"?>
+<p:notesMaster xmlns:a="http://schemas.openxmlformats.org/drawingml/2006/main" xmlns:r="http://schemas.openxmlformats.org/officeDocument/2006/relationships" xmlns:p="http://schemas.openxmlformats.org/presentationml/2006/main">
+  <p:cSld>
+    <p:bg>
+      <p:bgRef idx="1001">
+        <a:schemeClr val="bg1"/>
+      </p:bgRef>
+    </p:bg>
+    <p:spTree>
+      <p:nvGrpSpPr>
+        <p:cNvPr id="1" name=""/>
+        <p:cNvGrpSpPr/>
+        <p:nvPr/>
+      </p:nvGrpSpPr>
+      <p:grpSpPr>
+        <a:xfrm>
+          <a:off x="0" y="0"/>
+          <a:ext cx="0" cy="0"/>
+          <a:chOff x="0" y="0"/>
+          <a:chExt cx="0" cy="0"/>
+        </a:xfrm>
+      </p:grpSpPr>
+      <p:sp>
+        <p:nvSpPr>
+          <p:cNvPr id="2" name="Header Placeholder 1"/>
+          <p:cNvSpPr>
+            <a:spLocks noGrp="1"/>
+          </p:cNvSpPr>
+          <p:nvPr>
+            <p:ph type="hdr" sz="quarter"/>
+          </p:nvPr>
+        </p:nvSpPr>
+        <p:spPr>
+          <a:xfrm>
+            <a:off x="0" y="0"/>
+            <a:ext cx="2971800" cy="458788"/>
+          </a:xfrm>
+          <a:prstGeom prst="rect">
+            <a:avLst/>
+          </a:prstGeom>
+        </p:spPr>
+        <p:txBody>
+          <a:bodyPr vert="horz" lIns="91440" tIns="45720" rIns="91440" bIns="45720" rtlCol="0"/>
+          <a:lstStyle>
+            <a:lvl1pPr algn="l">
+              <a:defRPr sz="1200"/>
+            </a:lvl1pPr>
+          </a:lstStyle>
+          <a:p>
+            <a:endParaRPr lang="en-US"/>
+          </a:p>
+        </p:txBody>
+      </p:sp>
+      <p:sp>
+        <p:nvSpPr>
+          <p:cNvPr id="3" name="Date Placeholder 2"/>
+          <p:cNvSpPr>
+            <a:spLocks noGrp="1"/>
+          </p:cNvSpPr>
+          <p:nvPr>
+            <p:ph type="dt" idx="1"/>
+          </p:nvPr>
+        </p:nvSpPr>
+        <p:spPr>
+          <a:xfrm>
+            <a:off x="3884613" y="0"/>
+            <a:ext cx="2971800" cy="458788"/>
+          </a:xfrm>
+          <a:prstGeom prst="rect">
+            <a:avLst/>
+          </a:prstGeom>
+        </p:spPr>
+        <p:txBody>
+          <a:bodyPr vert="horz" lIns="91440" tIns="45720" rIns="91440" bIns="45720" rtlCol="0"/>
+          <a:lstStyle>
+            <a:lvl1pPr algn="r">
+              <a:defRPr sz="1200"/>
+            </a:lvl1pPr>
+          </a:lstStyle>
+          <a:p>
+            <a:fld id="{7F60D080-05B7-714C-85B1-3A50E05C0C84}" type="datetimeFigureOut">
+              <a:rPr lang="en-US" smtClean="0"/>
+              <a:t>3/23/26</a:t>
+            </a:fld>
+            <a:endParaRPr lang="en-US"/>
+          </a:p>
+        </p:txBody>
+      </p:sp>
+      <p:sp>
+        <p:nvSpPr>
+          <p:cNvPr id="4" name="Slide Image Placeholder 3"/>
+          <p:cNvSpPr>
+            <a:spLocks noGrp="1" noRot="1" noChangeAspect="1"/>
+          </p:cNvSpPr>
+          <p:nvPr>
+            <p:ph type="sldImg" idx="2"/>
+          </p:nvPr>
+        </p:nvSpPr>
+        <p:spPr>
+          <a:xfrm>
+            <a:off x="685800" y="1143000"/>
+            <a:ext cx="5486400" cy="3086100"/>
+          </a:xfrm>
+          <a:prstGeom prst="rect">
+            <a:avLst/>
+          </a:prstGeom>
+          <a:noFill/>
+          <a:ln w="12700">
+            <a:solidFill>
+              <a:prstClr val="black"/>
+            </a:solidFill>
+          </a:ln>
+        </p:spPr>
+        <p:txBody>
+          <a:bodyPr vert="horz" lIns="91440" tIns="45720" rIns="91440" bIns="45720" rtlCol="0" anchor="ctr"/>
+          <a:lstStyle/>
+          <a:p>
+            <a:endParaRPr lang="en-US"/>
+          </a:p>
+        </p:txBody>
+      </p:sp>
+      <p:sp>
+        <p:nvSpPr>
+          <p:cNvPr id="5" name="Notes Placeholder 4"/>
+          <p:cNvSpPr>
+            <a:spLocks noGrp="1"/>
+          </p:cNvSpPr>
+          <p:nvPr>
+            <p:ph type="body" sz="quarter" idx="3"/>
+          </p:nvPr>
+        </p:nvSpPr>
+        <p:spPr>
+          <a:xfrm>
+            <a:off x="685800" y="4400550"/>
+            <a:ext cx="5486400" cy="3600450"/>
+          </a:xfrm>
+          <a:prstGeom prst="rect">
+            <a:avLst/>
+          </a:prstGeom>
+        </p:spPr>
+        <p:txBody>
+          <a:bodyPr vert="horz" lIns="91440" tIns="45720" rIns="91440" bIns="45720" rtlCol="0"/>
+          <a:lstStyle/>
+          <a:p>
+            <a:pPr lvl="0"/>
+            <a:r>
+              <a:rPr lang="en-GB"/>
+              <a:t>Click to edit Master text styles</a:t>
+            </a:r>
+          </a:p>
+          <a:p>
+            <a:pPr lvl="1"/>
+            <a:r>
+              <a:rPr lang="en-GB"/>
+              <a:t>Second level</a:t>
+            </a:r>
+          </a:p>
+          <a:p>
+            <a:pPr lvl="2"/>
+            <a:r>
+              <a:rPr lang="en-GB"/>
+              <a:t>Third level</a:t>
+            </a:r>
+          </a:p>
+          <a:p>
+            <a:pPr lvl="3"/>
+            <a:r>
+              <a:rPr lang="en-GB"/>
+              <a:t>Fourth level</a:t>
+            </a:r>
+          </a:p>
+          <a:p>
+            <a:pPr lvl="4"/>
+            <a:r>
+              <a:rPr lang="en-GB"/>
+              <a:t>Fifth level</a:t>
+            </a:r>
+            <a:endParaRPr lang="en-US"/>
+          </a:p>
+        </p:txBody>
+      </p:sp>
+      <p:sp>
+        <p:nvSpPr>
+          <p:cNvPr id="6" name="Footer Placeholder 5"/>
+          <p:cNvSpPr>
+            <a:spLocks noGrp="1"/>
+          </p:cNvSpPr>
+          <p:nvPr>
+            <p:ph type="ftr" sz="quarter" idx="4"/>
+          </p:nvPr>
+        </p:nvSpPr>
+        <p:spPr>
+          <a:xfrm>
+            <a:off x="0" y="8685213"/>
+            <a:ext cx="2971800" cy="458787"/>
+          </a:xfrm>
+          <a:prstGeom prst="rect">
+            <a:avLst/>
+          </a:prstGeom>
+        </p:spPr>
+        <p:txBody>
+          <a:bodyPr vert="horz" lIns="91440" tIns="45720" rIns="91440" bIns="45720" rtlCol="0" anchor="b"/>
+          <a:lstStyle>
+            <a:lvl1pPr algn="l">
+              <a:defRPr sz="1200"/>
+            </a:lvl1pPr>
+          </a:lstStyle>
+          <a:p>
+            <a:endParaRPr lang="en-US"/>
+          </a:p>
+        </p:txBody>
+      </p:sp>
+      <p:sp>
+        <p:nvSpPr>
+          <p:cNvPr id="7" name="Slide Number Placeholder 6"/>
+          <p:cNvSpPr>
+            <a:spLocks noGrp="1"/>
+          </p:cNvSpPr>
+          <p:nvPr>
+            <p:ph type="sldNum" sz="quarter" idx="5"/>
+          </p:nvPr>
+        </p:nvSpPr>
+        <p:spPr>
+          <a:xfrm>
+            <a:off x="3884613" y="8685213"/>
+            <a:ext cx="2971800" cy="458787"/>
+          </a:xfrm>
+          <a:prstGeom prst="rect">
+            <a:avLst/>
+          </a:prstGeom>
+        </p:spPr>
+        <p:txBody>
+          <a:bodyPr vert="horz" lIns="91440" tIns="45720" rIns="91440" bIns="45720" rtlCol="0" anchor="b"/>
+          <a:lstStyle>
+            <a:lvl1pPr algn="r">
+              <a:defRPr sz="1200"/>
+            </a:lvl1pPr>
+          </a:lstStyle>
+          <a:p>
+            <a:fld id="{439B116B-03C7-E044-B44C-E435BA19A11B}" type="slidenum">
+              <a:rPr lang="en-US" smtClean="0"/>
+              <a:t>‹#›</a:t>
+            </a:fld>
+            <a:endParaRPr lang="en-US"/>
+          </a:p>
+        </p:txBody>
+      </p:sp>
+    </p:spTree>
+    <p:extLst>
+      <p:ext uri="{BB962C8B-B14F-4D97-AF65-F5344CB8AC3E}">
+        <p14:creationId xmlns:p14="http://schemas.microsoft.com/office/powerpoint/2010/main" val="2920596776"/>
+      </p:ext>
+    </p:extLst>
+  </p:cSld>
+  <p:clrMap bg1="lt1" tx1="dk1" bg2="lt2" tx2="dk2" accent1="accent1" accent2="accent2" accent3="accent3" accent4="accent4" accent5="accent5" accent6="accent6" hlink="hlink" folHlink="folHlink"/>
+  <p:notesStyle>
+    <a:lvl1pPr marL="0" algn="l" defTabSz="914400" rtl="0" eaLnBrk="1" latinLnBrk="0" hangingPunct="1">
+      <a:defRPr sz="1200" kern="1200">
+        <a:solidFill>
+          <a:schemeClr val="tx1"/>
+        </a:solidFill>
+        <a:latin typeface="+mn-lt"/>
+        <a:ea typeface="+mn-ea"/>
+        <a:cs typeface="+mn-cs"/>
+      </a:defRPr>
+    </a:lvl1pPr>
+    <a:lvl2pPr marL="457200" algn="l" defTabSz="914400" rtl="0" eaLnBrk="1" latinLnBrk="0" hangingPunct="1">
+      <a:defRPr sz="1200" kern="1200">
+        <a:solidFill>
+          <a:schemeClr val="tx1"/>
+        </a:solidFill>
+        <a:latin typeface="+mn-lt"/>
+        <a:ea typeface="+mn-ea"/>
+        <a:cs typeface="+mn-cs"/>
+      </a:defRPr>
+    </a:lvl2pPr>
+    <a:lvl3pPr marL="914400" algn="l" defTabSz="914400" rtl="0" eaLnBrk="1" latinLnBrk="0" hangingPunct="1">
+      <a:defRPr sz="1200" kern="1200">
+        <a:solidFill>
+          <a:schemeClr val="tx1"/>
+        </a:solidFill>
+        <a:latin typeface="+mn-lt"/>
+        <a:ea typeface="+mn-ea"/>
+        <a:cs typeface="+mn-cs"/>
+      </a:defRPr>
+    </a:lvl3pPr>
+    <a:lvl4pPr marL="1371600" algn="l" defTabSz="914400" rtl="0" eaLnBrk="1" latinLnBrk="0" hangingPunct="1">
+      <a:defRPr sz="1200" kern="1200">
+        <a:solidFill>
+          <a:schemeClr val="tx1"/>
+        </a:solidFill>
+        <a:latin typeface="+mn-lt"/>
+        <a:ea typeface="+mn-ea"/>
+        <a:cs typeface="+mn-cs"/>
+      </a:defRPr>
+    </a:lvl4pPr>
+    <a:lvl5pPr marL="1828800" algn="l" defTabSz="914400" rtl="0" eaLnBrk="1" latinLnBrk="0" hangingPunct="1">
+      <a:defRPr sz="1200" kern="1200">
+        <a:solidFill>
+          <a:schemeClr val="tx1"/>
+        </a:solidFill>
+        <a:latin typeface="+mn-lt"/>
+        <a:ea typeface="+mn-ea"/>
+        <a:cs typeface="+mn-cs"/>
+      </a:defRPr>
+    </a:lvl5pPr>
+    <a:lvl6pPr marL="2286000" algn="l" defTabSz="914400" rtl="0" eaLnBrk="1" latinLnBrk="0" hangingPunct="1">
+      <a:defRPr sz="1200" kern="1200">
+        <a:solidFill>
+          <a:schemeClr val="tx1"/>
+        </a:solidFill>
+        <a:latin typeface="+mn-lt"/>
+        <a:ea typeface="+mn-ea"/>
+        <a:cs typeface="+mn-cs"/>
+      </a:defRPr>
+    </a:lvl6pPr>
+    <a:lvl7pPr marL="2743200" algn="l" defTabSz="914400" rtl="0" eaLnBrk="1" latinLnBrk="0" hangingPunct="1">
+      <a:defRPr sz="1200" kern="1200">
+        <a:solidFill>
+          <a:schemeClr val="tx1"/>
+        </a:solidFill>
+        <a:latin typeface="+mn-lt"/>
+        <a:ea typeface="+mn-ea"/>
+        <a:cs typeface="+mn-cs"/>
+      </a:defRPr>
+    </a:lvl7pPr>
+    <a:lvl8pPr marL="3200400" algn="l" defTabSz="914400" rtl="0" eaLnBrk="1" latinLnBrk="0" hangingPunct="1">
+      <a:defRPr sz="1200" kern="1200">
+        <a:solidFill>
+          <a:schemeClr val="tx1"/>
+        </a:solidFill>
+        <a:latin typeface="+mn-lt"/>
+        <a:ea typeface="+mn-ea"/>
+        <a:cs typeface="+mn-cs"/>
+      </a:defRPr>
+    </a:lvl8pPr>
+    <a:lvl9pPr marL="3657600" algn="l" defTabSz="914400" rtl="0" eaLnBrk="1" latinLnBrk="0" hangingPunct="1">
+      <a:defRPr sz="1200" kern="1200">
+        <a:solidFill>
+          <a:schemeClr val="tx1"/>
+        </a:solidFill>
+        <a:latin typeface="+mn-lt"/>
+        <a:ea typeface="+mn-ea"/>
+        <a:cs typeface="+mn-cs"/>
+      </a:defRPr>
+    </a:lvl9pPr>
+  </p:notesStyle>
+</p:notesMaster>
+</file>
+
+<file path=ppt/notesSlides/notesSlide1.xml><?xml version="1.0" encoding="utf-8"?>
+<p:notes xmlns:a="http://schemas.openxmlformats.org/drawingml/2006/main" xmlns:r="http://schemas.openxmlformats.org/officeDocument/2006/relationships" xmlns:p="http://schemas.openxmlformats.org/presentationml/2006/main">
+  <p:cSld>
+    <p:spTree>
+      <p:nvGrpSpPr>
+        <p:cNvPr id="1" name="">
+          <a:extLst>
+            <a:ext uri="{FF2B5EF4-FFF2-40B4-BE49-F238E27FC236}">
+              <a16:creationId xmlns:a16="http://schemas.microsoft.com/office/drawing/2014/main" id="{6E6CBA8C-B68B-60C1-1765-0A270F6E34DF}"/>
+            </a:ext>
+          </a:extLst>
+        </p:cNvPr>
+        <p:cNvGrpSpPr/>
+        <p:nvPr/>
+      </p:nvGrpSpPr>
+      <p:grpSpPr>
+        <a:xfrm>
+          <a:off x="0" y="0"/>
+          <a:ext cx="0" cy="0"/>
+          <a:chOff x="0" y="0"/>
+          <a:chExt cx="0" cy="0"/>
+        </a:xfrm>
+      </p:grpSpPr>
+      <p:sp>
+        <p:nvSpPr>
+          <p:cNvPr id="2" name="Slide Image Placeholder 1">
+            <a:extLst>
+              <a:ext uri="{FF2B5EF4-FFF2-40B4-BE49-F238E27FC236}">
+                <a16:creationId xmlns:a16="http://schemas.microsoft.com/office/drawing/2014/main" id="{7AAA8050-29F3-8189-F7E1-F284D4C52B60}"/>
+              </a:ext>
+            </a:extLst>
+          </p:cNvPr>
+          <p:cNvSpPr>
+            <a:spLocks noGrp="1" noRot="1" noChangeAspect="1"/>
+          </p:cNvSpPr>
+          <p:nvPr>
+            <p:ph type="sldImg"/>
+          </p:nvPr>
+        </p:nvSpPr>
+        <p:spPr/>
+      </p:sp>
+      <p:sp>
+        <p:nvSpPr>
+          <p:cNvPr id="3" name="Notes Placeholder 2">
+            <a:extLst>
+              <a:ext uri="{FF2B5EF4-FFF2-40B4-BE49-F238E27FC236}">
+                <a16:creationId xmlns:a16="http://schemas.microsoft.com/office/drawing/2014/main" id="{2BEBA8EF-7C20-F0F4-7F1F-67CDD0AF2AA2}"/>
+              </a:ext>
+            </a:extLst>
+          </p:cNvPr>
+          <p:cNvSpPr>
+            <a:spLocks noGrp="1"/>
+          </p:cNvSpPr>
+          <p:nvPr>
+            <p:ph type="body" idx="1"/>
+          </p:nvPr>
+        </p:nvSpPr>
+        <p:spPr/>
+        <p:txBody>
+          <a:bodyPr/>
+          <a:lstStyle/>
+          <a:p>
+            <a:r>
+              <a:rPr lang="en-IN" sz="1200" b="0" i="0" kern="1200" dirty="0">
+                <a:solidFill>
+                  <a:schemeClr val="tx1"/>
+                </a:solidFill>
+                <a:effectLst/>
+                <a:latin typeface="+mn-lt"/>
+                <a:ea typeface="+mn-ea"/>
+                <a:cs typeface="+mn-cs"/>
+              </a:rPr>
+              <a:t>Future potential includes AJO and Adobe Campaign integration for multilingual emails, enhanced RAG with domain-specific compliance, and culture-aware A/B testing across markets.</a:t>
+            </a:r>
+          </a:p>
+          <a:p>
+            <a:endParaRPr lang="en-IN" sz="1200" b="0" i="0" kern="1200" dirty="0">
+              <a:solidFill>
+                <a:schemeClr val="tx1"/>
+              </a:solidFill>
+              <a:effectLst/>
+              <a:latin typeface="+mn-lt"/>
+              <a:ea typeface="+mn-ea"/>
+              <a:cs typeface="+mn-cs"/>
+            </a:endParaRPr>
+          </a:p>
+          <a:p>
+            <a:r>
+              <a:rPr lang="en-IN" sz="1200" b="0" i="0" kern="1200" dirty="0">
+                <a:solidFill>
+                  <a:schemeClr val="tx1"/>
+                </a:solidFill>
+                <a:effectLst/>
+                <a:latin typeface="+mn-lt"/>
+                <a:ea typeface="+mn-ea"/>
+                <a:cs typeface="+mn-cs"/>
+              </a:rPr>
+              <a:t>Thank you!</a:t>
+            </a:r>
+            <a:endParaRPr lang="en-US" dirty="0"/>
+          </a:p>
+        </p:txBody>
+      </p:sp>
+      <p:sp>
+        <p:nvSpPr>
+          <p:cNvPr id="4" name="Slide Number Placeholder 3">
+            <a:extLst>
+              <a:ext uri="{FF2B5EF4-FFF2-40B4-BE49-F238E27FC236}">
+                <a16:creationId xmlns:a16="http://schemas.microsoft.com/office/drawing/2014/main" id="{C00E3E14-26A8-8DE2-7507-4E3CEACAE916}"/>
+              </a:ext>
+            </a:extLst>
+          </p:cNvPr>
+          <p:cNvSpPr>
+            <a:spLocks noGrp="1"/>
+          </p:cNvSpPr>
+          <p:nvPr>
+            <p:ph type="sldNum" sz="quarter" idx="5"/>
+          </p:nvPr>
+        </p:nvSpPr>
+        <p:spPr/>
+        <p:txBody>
+          <a:bodyPr/>
+          <a:lstStyle/>
+          <a:p>
+            <a:fld id="{3EF2277D-4E65-471B-8FDC-312617F5EA89}" type="slidenum">
+              <a:rPr lang="en-US" smtClean="0"/>
+              <a:pPr/>
+              <a:t>3</a:t>
+            </a:fld>
+            <a:endParaRPr lang="en-US" dirty="0"/>
+          </a:p>
+        </p:txBody>
+      </p:sp>
+    </p:spTree>
+    <p:extLst>
+      <p:ext uri="{BB962C8B-B14F-4D97-AF65-F5344CB8AC3E}">
+        <p14:creationId xmlns:p14="http://schemas.microsoft.com/office/powerpoint/2010/main" val="736322757"/>
+      </p:ext>
+    </p:extLst>
+  </p:cSld>
+  <p:clrMapOvr>
+    <a:masterClrMapping/>
+  </p:clrMapOvr>
+</p:notes>
 </file>
 
 <file path=ppt/slideLayouts/slideLayout1.xml><?xml version="1.0" encoding="utf-8"?>
@@ -169,10 +685,9 @@
           <a:lstStyle/>
           <a:p>
             <a:r>
-              <a:rPr lang="en-US" smtClean="0"/>
+              <a:rPr lang="en-US"/>
               <a:t>Click to edit Master title style</a:t>
             </a:r>
-            <a:endParaRPr lang="en-US"/>
           </a:p>
         </p:txBody>
       </p:sp>
@@ -288,10 +803,9 @@
           </a:lstStyle>
           <a:p>
             <a:r>
-              <a:rPr lang="en-US" smtClean="0"/>
+              <a:rPr lang="en-US"/>
               <a:t>Click to edit Master subtitle style</a:t>
             </a:r>
-            <a:endParaRPr lang="en-US"/>
           </a:p>
         </p:txBody>
       </p:sp>
@@ -312,7 +826,7 @@
           <a:p>
             <a:fld id="{5BCAD085-E8A6-8845-BD4E-CB4CCA059FC4}" type="datetimeFigureOut">
               <a:rPr lang="en-US" smtClean="0"/>
-              <a:t>1/27/13</a:t>
+              <a:t>3/23/26</a:t>
             </a:fld>
             <a:endParaRPr lang="en-US"/>
           </a:p>
@@ -406,10 +920,9 @@
           <a:lstStyle/>
           <a:p>
             <a:r>
-              <a:rPr lang="en-US" smtClean="0"/>
+              <a:rPr lang="en-US"/>
               <a:t>Click to edit Master title style</a:t>
             </a:r>
-            <a:endParaRPr lang="en-US"/>
           </a:p>
         </p:txBody>
       </p:sp>
@@ -430,38 +943,37 @@
           <a:p>
             <a:pPr lvl="0"/>
             <a:r>
-              <a:rPr lang="en-US" smtClean="0"/>
+              <a:rPr lang="en-US"/>
               <a:t>Click to edit Master text styles</a:t>
             </a:r>
           </a:p>
           <a:p>
             <a:pPr lvl="1"/>
             <a:r>
-              <a:rPr lang="en-US" smtClean="0"/>
+              <a:rPr lang="en-US"/>
               <a:t>Second level</a:t>
             </a:r>
           </a:p>
           <a:p>
             <a:pPr lvl="2"/>
             <a:r>
-              <a:rPr lang="en-US" smtClean="0"/>
+              <a:rPr lang="en-US"/>
               <a:t>Third level</a:t>
             </a:r>
           </a:p>
           <a:p>
             <a:pPr lvl="3"/>
             <a:r>
-              <a:rPr lang="en-US" smtClean="0"/>
+              <a:rPr lang="en-US"/>
               <a:t>Fourth level</a:t>
             </a:r>
           </a:p>
           <a:p>
             <a:pPr lvl="4"/>
             <a:r>
-              <a:rPr lang="en-US" smtClean="0"/>
+              <a:rPr lang="en-US"/>
               <a:t>Fifth level</a:t>
             </a:r>
-            <a:endParaRPr lang="en-US"/>
           </a:p>
         </p:txBody>
       </p:sp>
@@ -482,7 +994,7 @@
           <a:p>
             <a:fld id="{5BCAD085-E8A6-8845-BD4E-CB4CCA059FC4}" type="datetimeFigureOut">
               <a:rPr lang="en-US" smtClean="0"/>
-              <a:t>1/27/13</a:t>
+              <a:t>3/23/26</a:t>
             </a:fld>
             <a:endParaRPr lang="en-US"/>
           </a:p>
@@ -581,10 +1093,9 @@
           <a:lstStyle/>
           <a:p>
             <a:r>
-              <a:rPr lang="en-US" smtClean="0"/>
+              <a:rPr lang="en-US"/>
               <a:t>Click to edit Master title style</a:t>
             </a:r>
-            <a:endParaRPr lang="en-US"/>
           </a:p>
         </p:txBody>
       </p:sp>
@@ -610,38 +1121,37 @@
           <a:p>
             <a:pPr lvl="0"/>
             <a:r>
-              <a:rPr lang="en-US" smtClean="0"/>
+              <a:rPr lang="en-US"/>
               <a:t>Click to edit Master text styles</a:t>
             </a:r>
           </a:p>
           <a:p>
             <a:pPr lvl="1"/>
             <a:r>
-              <a:rPr lang="en-US" smtClean="0"/>
+              <a:rPr lang="en-US"/>
               <a:t>Second level</a:t>
             </a:r>
           </a:p>
           <a:p>
             <a:pPr lvl="2"/>
             <a:r>
-              <a:rPr lang="en-US" smtClean="0"/>
+              <a:rPr lang="en-US"/>
               <a:t>Third level</a:t>
             </a:r>
           </a:p>
           <a:p>
             <a:pPr lvl="3"/>
             <a:r>
-              <a:rPr lang="en-US" smtClean="0"/>
+              <a:rPr lang="en-US"/>
               <a:t>Fourth level</a:t>
             </a:r>
           </a:p>
           <a:p>
             <a:pPr lvl="4"/>
             <a:r>
-              <a:rPr lang="en-US" smtClean="0"/>
+              <a:rPr lang="en-US"/>
               <a:t>Fifth level</a:t>
             </a:r>
-            <a:endParaRPr lang="en-US"/>
           </a:p>
         </p:txBody>
       </p:sp>
@@ -662,7 +1172,7 @@
           <a:p>
             <a:fld id="{5BCAD085-E8A6-8845-BD4E-CB4CCA059FC4}" type="datetimeFigureOut">
               <a:rPr lang="en-US" smtClean="0"/>
-              <a:t>1/27/13</a:t>
+              <a:t>3/23/26</a:t>
             </a:fld>
             <a:endParaRPr lang="en-US"/>
           </a:p>
@@ -714,6 +1224,206 @@
     <p:extLst>
       <p:ext uri="{BB962C8B-B14F-4D97-AF65-F5344CB8AC3E}">
         <p14:creationId xmlns:p14="http://schemas.microsoft.com/office/powerpoint/2010/main" val="3612223792"/>
+      </p:ext>
+    </p:extLst>
+  </p:cSld>
+  <p:clrMapOvr>
+    <a:masterClrMapping/>
+  </p:clrMapOvr>
+</p:sldLayout>
+</file>
+
+<file path=ppt/slideLayouts/slideLayout12.xml><?xml version="1.0" encoding="utf-8"?>
+<p:sldLayout xmlns:a="http://schemas.openxmlformats.org/drawingml/2006/main" xmlns:r="http://schemas.openxmlformats.org/officeDocument/2006/relationships" xmlns:p="http://schemas.openxmlformats.org/presentationml/2006/main" userDrawn="1">
+  <p:cSld name="Section Title: Adobe Marketing Cloud">
+    <p:spTree>
+      <p:nvGrpSpPr>
+        <p:cNvPr id="1" name=""/>
+        <p:cNvGrpSpPr/>
+        <p:nvPr/>
+      </p:nvGrpSpPr>
+      <p:grpSpPr>
+        <a:xfrm>
+          <a:off x="0" y="0"/>
+          <a:ext cx="0" cy="0"/>
+          <a:chOff x="0" y="0"/>
+          <a:chExt cx="0" cy="0"/>
+        </a:xfrm>
+      </p:grpSpPr>
+      <p:sp>
+        <p:nvSpPr>
+          <p:cNvPr id="10" name="Title 1">
+            <a:extLst>
+              <a:ext uri="{FF2B5EF4-FFF2-40B4-BE49-F238E27FC236}">
+                <a16:creationId xmlns:a16="http://schemas.microsoft.com/office/drawing/2014/main" id="{D2D5F9C8-6C5B-4F2B-99BF-54F187A0ACA9}"/>
+              </a:ext>
+            </a:extLst>
+          </p:cNvPr>
+          <p:cNvSpPr>
+            <a:spLocks noGrp="1"/>
+          </p:cNvSpPr>
+          <p:nvPr>
+            <p:ph type="ctrTitle"/>
+          </p:nvPr>
+        </p:nvSpPr>
+        <p:spPr>
+          <a:xfrm>
+            <a:off x="641349" y="1371644"/>
+            <a:ext cx="10921064" cy="677108"/>
+          </a:xfrm>
+        </p:spPr>
+        <p:txBody>
+          <a:bodyPr wrap="square" lIns="0" tIns="0" rIns="0" bIns="0">
+            <a:spAutoFit/>
+          </a:bodyPr>
+          <a:lstStyle>
+            <a:lvl1pPr>
+              <a:defRPr>
+                <a:solidFill>
+                  <a:schemeClr val="bg1"/>
+                </a:solidFill>
+                <a:latin typeface="Adobe Clean Light" pitchFamily="34" charset="0"/>
+              </a:defRPr>
+            </a:lvl1pPr>
+          </a:lstStyle>
+          <a:p>
+            <a:r>
+              <a:rPr lang="en-US"/>
+              <a:t>Click to edit Master title style</a:t>
+            </a:r>
+          </a:p>
+        </p:txBody>
+      </p:sp>
+      <p:sp>
+        <p:nvSpPr>
+          <p:cNvPr id="11" name="Subtitle 2">
+            <a:extLst>
+              <a:ext uri="{FF2B5EF4-FFF2-40B4-BE49-F238E27FC236}">
+                <a16:creationId xmlns:a16="http://schemas.microsoft.com/office/drawing/2014/main" id="{0B31D6AB-5031-4ED1-99F4-F87633ECCE64}"/>
+              </a:ext>
+            </a:extLst>
+          </p:cNvPr>
+          <p:cNvSpPr>
+            <a:spLocks noGrp="1"/>
+          </p:cNvSpPr>
+          <p:nvPr>
+            <p:ph type="subTitle" idx="1"/>
+          </p:nvPr>
+        </p:nvSpPr>
+        <p:spPr>
+          <a:xfrm>
+            <a:off x="641349" y="1990491"/>
+            <a:ext cx="10921064" cy="328295"/>
+          </a:xfrm>
+        </p:spPr>
+        <p:txBody>
+          <a:bodyPr wrap="square" lIns="0" tIns="0" rIns="0" bIns="0">
+            <a:spAutoFit/>
+          </a:bodyPr>
+          <a:lstStyle>
+            <a:lvl1pPr marL="0" indent="0" algn="l">
+              <a:buNone/>
+              <a:defRPr sz="2100">
+                <a:solidFill>
+                  <a:schemeClr val="bg1">
+                    <a:lumMod val="75000"/>
+                  </a:schemeClr>
+                </a:solidFill>
+              </a:defRPr>
+            </a:lvl1pPr>
+            <a:lvl2pPr marL="544145" indent="0" algn="ctr">
+              <a:buNone/>
+              <a:defRPr>
+                <a:solidFill>
+                  <a:schemeClr val="tx1">
+                    <a:tint val="75000"/>
+                  </a:schemeClr>
+                </a:solidFill>
+              </a:defRPr>
+            </a:lvl2pPr>
+            <a:lvl3pPr marL="1088291" indent="0" algn="ctr">
+              <a:buNone/>
+              <a:defRPr>
+                <a:solidFill>
+                  <a:schemeClr val="tx1">
+                    <a:tint val="75000"/>
+                  </a:schemeClr>
+                </a:solidFill>
+              </a:defRPr>
+            </a:lvl3pPr>
+            <a:lvl4pPr marL="1632436" indent="0" algn="ctr">
+              <a:buNone/>
+              <a:defRPr>
+                <a:solidFill>
+                  <a:schemeClr val="tx1">
+                    <a:tint val="75000"/>
+                  </a:schemeClr>
+                </a:solidFill>
+              </a:defRPr>
+            </a:lvl4pPr>
+            <a:lvl5pPr marL="2176581" indent="0" algn="ctr">
+              <a:buNone/>
+              <a:defRPr>
+                <a:solidFill>
+                  <a:schemeClr val="tx1">
+                    <a:tint val="75000"/>
+                  </a:schemeClr>
+                </a:solidFill>
+              </a:defRPr>
+            </a:lvl5pPr>
+            <a:lvl6pPr marL="2720726" indent="0" algn="ctr">
+              <a:buNone/>
+              <a:defRPr>
+                <a:solidFill>
+                  <a:schemeClr val="tx1">
+                    <a:tint val="75000"/>
+                  </a:schemeClr>
+                </a:solidFill>
+              </a:defRPr>
+            </a:lvl6pPr>
+            <a:lvl7pPr marL="3264872" indent="0" algn="ctr">
+              <a:buNone/>
+              <a:defRPr>
+                <a:solidFill>
+                  <a:schemeClr val="tx1">
+                    <a:tint val="75000"/>
+                  </a:schemeClr>
+                </a:solidFill>
+              </a:defRPr>
+            </a:lvl7pPr>
+            <a:lvl8pPr marL="3809017" indent="0" algn="ctr">
+              <a:buNone/>
+              <a:defRPr>
+                <a:solidFill>
+                  <a:schemeClr val="tx1">
+                    <a:tint val="75000"/>
+                  </a:schemeClr>
+                </a:solidFill>
+              </a:defRPr>
+            </a:lvl8pPr>
+            <a:lvl9pPr marL="4353162" indent="0" algn="ctr">
+              <a:buNone/>
+              <a:defRPr>
+                <a:solidFill>
+                  <a:schemeClr val="tx1">
+                    <a:tint val="75000"/>
+                  </a:schemeClr>
+                </a:solidFill>
+              </a:defRPr>
+            </a:lvl9pPr>
+          </a:lstStyle>
+          <a:p>
+            <a:r>
+              <a:rPr lang="en-US"/>
+              <a:t>Click to edit Master subtitle style</a:t>
+            </a:r>
+          </a:p>
+        </p:txBody>
+      </p:sp>
+    </p:spTree>
+    <p:extLst>
+      <p:ext uri="{BB962C8B-B14F-4D97-AF65-F5344CB8AC3E}">
+        <p14:creationId xmlns:p14="http://schemas.microsoft.com/office/powerpoint/2010/main" val="4214154303"/>
       </p:ext>
     </p:extLst>
   </p:cSld>
@@ -756,10 +1466,9 @@
           <a:lstStyle/>
           <a:p>
             <a:r>
-              <a:rPr lang="en-US" smtClean="0"/>
+              <a:rPr lang="en-US"/>
               <a:t>Click to edit Master title style</a:t>
             </a:r>
-            <a:endParaRPr lang="en-US"/>
           </a:p>
         </p:txBody>
       </p:sp>
@@ -780,38 +1489,37 @@
           <a:p>
             <a:pPr lvl="0"/>
             <a:r>
-              <a:rPr lang="en-US" smtClean="0"/>
+              <a:rPr lang="en-US"/>
               <a:t>Click to edit Master text styles</a:t>
             </a:r>
           </a:p>
           <a:p>
             <a:pPr lvl="1"/>
             <a:r>
-              <a:rPr lang="en-US" smtClean="0"/>
+              <a:rPr lang="en-US"/>
               <a:t>Second level</a:t>
             </a:r>
           </a:p>
           <a:p>
             <a:pPr lvl="2"/>
             <a:r>
-              <a:rPr lang="en-US" smtClean="0"/>
+              <a:rPr lang="en-US"/>
               <a:t>Third level</a:t>
             </a:r>
           </a:p>
           <a:p>
             <a:pPr lvl="3"/>
             <a:r>
-              <a:rPr lang="en-US" smtClean="0"/>
+              <a:rPr lang="en-US"/>
               <a:t>Fourth level</a:t>
             </a:r>
           </a:p>
           <a:p>
             <a:pPr lvl="4"/>
             <a:r>
-              <a:rPr lang="en-US" smtClean="0"/>
+              <a:rPr lang="en-US"/>
               <a:t>Fifth level</a:t>
             </a:r>
-            <a:endParaRPr lang="en-US"/>
           </a:p>
         </p:txBody>
       </p:sp>
@@ -832,7 +1540,7 @@
           <a:p>
             <a:fld id="{5BCAD085-E8A6-8845-BD4E-CB4CCA059FC4}" type="datetimeFigureOut">
               <a:rPr lang="en-US" smtClean="0"/>
-              <a:t>1/27/13</a:t>
+              <a:t>3/23/26</a:t>
             </a:fld>
             <a:endParaRPr lang="en-US"/>
           </a:p>
@@ -935,10 +1643,9 @@
           </a:lstStyle>
           <a:p>
             <a:r>
-              <a:rPr lang="en-US" smtClean="0"/>
+              <a:rPr lang="en-US"/>
               <a:t>Click to edit Master title style</a:t>
             </a:r>
-            <a:endParaRPr lang="en-US"/>
           </a:p>
         </p:txBody>
       </p:sp>
@@ -1055,7 +1762,7 @@
           <a:p>
             <a:pPr lvl="0"/>
             <a:r>
-              <a:rPr lang="en-US" smtClean="0"/>
+              <a:rPr lang="en-US"/>
               <a:t>Click to edit Master text styles</a:t>
             </a:r>
           </a:p>
@@ -1078,7 +1785,7 @@
           <a:p>
             <a:fld id="{5BCAD085-E8A6-8845-BD4E-CB4CCA059FC4}" type="datetimeFigureOut">
               <a:rPr lang="en-US" smtClean="0"/>
-              <a:t>1/27/13</a:t>
+              <a:t>3/23/26</a:t>
             </a:fld>
             <a:endParaRPr lang="en-US"/>
           </a:p>
@@ -1172,10 +1879,9 @@
           <a:lstStyle/>
           <a:p>
             <a:r>
-              <a:rPr lang="en-US" smtClean="0"/>
+              <a:rPr lang="en-US"/>
               <a:t>Click to edit Master title style</a:t>
             </a:r>
-            <a:endParaRPr lang="en-US"/>
           </a:p>
         </p:txBody>
       </p:sp>
@@ -1229,38 +1935,37 @@
           <a:p>
             <a:pPr lvl="0"/>
             <a:r>
-              <a:rPr lang="en-US" smtClean="0"/>
+              <a:rPr lang="en-US"/>
               <a:t>Click to edit Master text styles</a:t>
             </a:r>
           </a:p>
           <a:p>
             <a:pPr lvl="1"/>
             <a:r>
-              <a:rPr lang="en-US" smtClean="0"/>
+              <a:rPr lang="en-US"/>
               <a:t>Second level</a:t>
             </a:r>
           </a:p>
           <a:p>
             <a:pPr lvl="2"/>
             <a:r>
-              <a:rPr lang="en-US" smtClean="0"/>
+              <a:rPr lang="en-US"/>
               <a:t>Third level</a:t>
             </a:r>
           </a:p>
           <a:p>
             <a:pPr lvl="3"/>
             <a:r>
-              <a:rPr lang="en-US" smtClean="0"/>
+              <a:rPr lang="en-US"/>
               <a:t>Fourth level</a:t>
             </a:r>
           </a:p>
           <a:p>
             <a:pPr lvl="4"/>
             <a:r>
-              <a:rPr lang="en-US" smtClean="0"/>
+              <a:rPr lang="en-US"/>
               <a:t>Fifth level</a:t>
             </a:r>
-            <a:endParaRPr lang="en-US"/>
           </a:p>
         </p:txBody>
       </p:sp>
@@ -1314,38 +2019,37 @@
           <a:p>
             <a:pPr lvl="0"/>
             <a:r>
-              <a:rPr lang="en-US" smtClean="0"/>
+              <a:rPr lang="en-US"/>
               <a:t>Click to edit Master text styles</a:t>
             </a:r>
           </a:p>
           <a:p>
             <a:pPr lvl="1"/>
             <a:r>
-              <a:rPr lang="en-US" smtClean="0"/>
+              <a:rPr lang="en-US"/>
               <a:t>Second level</a:t>
             </a:r>
           </a:p>
           <a:p>
             <a:pPr lvl="2"/>
             <a:r>
-              <a:rPr lang="en-US" smtClean="0"/>
+              <a:rPr lang="en-US"/>
               <a:t>Third level</a:t>
             </a:r>
           </a:p>
           <a:p>
             <a:pPr lvl="3"/>
             <a:r>
-              <a:rPr lang="en-US" smtClean="0"/>
+              <a:rPr lang="en-US"/>
               <a:t>Fourth level</a:t>
             </a:r>
           </a:p>
           <a:p>
             <a:pPr lvl="4"/>
             <a:r>
-              <a:rPr lang="en-US" smtClean="0"/>
+              <a:rPr lang="en-US"/>
               <a:t>Fifth level</a:t>
             </a:r>
-            <a:endParaRPr lang="en-US"/>
           </a:p>
         </p:txBody>
       </p:sp>
@@ -1366,7 +2070,7 @@
           <a:p>
             <a:fld id="{5BCAD085-E8A6-8845-BD4E-CB4CCA059FC4}" type="datetimeFigureOut">
               <a:rPr lang="en-US" smtClean="0"/>
-              <a:t>1/27/13</a:t>
+              <a:t>3/23/26</a:t>
             </a:fld>
             <a:endParaRPr lang="en-US"/>
           </a:p>
@@ -1464,10 +2168,9 @@
           </a:lstStyle>
           <a:p>
             <a:r>
-              <a:rPr lang="en-US" smtClean="0"/>
+              <a:rPr lang="en-US"/>
               <a:t>Click to edit Master title style</a:t>
             </a:r>
-            <a:endParaRPr lang="en-US"/>
           </a:p>
         </p:txBody>
       </p:sp>
@@ -1530,7 +2233,7 @@
           <a:p>
             <a:pPr lvl="0"/>
             <a:r>
-              <a:rPr lang="en-US" smtClean="0"/>
+              <a:rPr lang="en-US"/>
               <a:t>Click to edit Master text styles</a:t>
             </a:r>
           </a:p>
@@ -1586,38 +2289,37 @@
           <a:p>
             <a:pPr lvl="0"/>
             <a:r>
-              <a:rPr lang="en-US" smtClean="0"/>
+              <a:rPr lang="en-US"/>
               <a:t>Click to edit Master text styles</a:t>
             </a:r>
           </a:p>
           <a:p>
             <a:pPr lvl="1"/>
             <a:r>
-              <a:rPr lang="en-US" smtClean="0"/>
+              <a:rPr lang="en-US"/>
               <a:t>Second level</a:t>
             </a:r>
           </a:p>
           <a:p>
             <a:pPr lvl="2"/>
             <a:r>
-              <a:rPr lang="en-US" smtClean="0"/>
+              <a:rPr lang="en-US"/>
               <a:t>Third level</a:t>
             </a:r>
           </a:p>
           <a:p>
             <a:pPr lvl="3"/>
             <a:r>
-              <a:rPr lang="en-US" smtClean="0"/>
+              <a:rPr lang="en-US"/>
               <a:t>Fourth level</a:t>
             </a:r>
           </a:p>
           <a:p>
             <a:pPr lvl="4"/>
             <a:r>
-              <a:rPr lang="en-US" smtClean="0"/>
+              <a:rPr lang="en-US"/>
               <a:t>Fifth level</a:t>
             </a:r>
-            <a:endParaRPr lang="en-US"/>
           </a:p>
         </p:txBody>
       </p:sp>
@@ -1680,7 +2382,7 @@
           <a:p>
             <a:pPr lvl="0"/>
             <a:r>
-              <a:rPr lang="en-US" smtClean="0"/>
+              <a:rPr lang="en-US"/>
               <a:t>Click to edit Master text styles</a:t>
             </a:r>
           </a:p>
@@ -1736,38 +2438,37 @@
           <a:p>
             <a:pPr lvl="0"/>
             <a:r>
-              <a:rPr lang="en-US" smtClean="0"/>
+              <a:rPr lang="en-US"/>
               <a:t>Click to edit Master text styles</a:t>
             </a:r>
           </a:p>
           <a:p>
             <a:pPr lvl="1"/>
             <a:r>
-              <a:rPr lang="en-US" smtClean="0"/>
+              <a:rPr lang="en-US"/>
               <a:t>Second level</a:t>
             </a:r>
           </a:p>
           <a:p>
             <a:pPr lvl="2"/>
             <a:r>
-              <a:rPr lang="en-US" smtClean="0"/>
+              <a:rPr lang="en-US"/>
               <a:t>Third level</a:t>
             </a:r>
           </a:p>
           <a:p>
             <a:pPr lvl="3"/>
             <a:r>
-              <a:rPr lang="en-US" smtClean="0"/>
+              <a:rPr lang="en-US"/>
               <a:t>Fourth level</a:t>
             </a:r>
           </a:p>
           <a:p>
             <a:pPr lvl="4"/>
             <a:r>
-              <a:rPr lang="en-US" smtClean="0"/>
+              <a:rPr lang="en-US"/>
               <a:t>Fifth level</a:t>
             </a:r>
-            <a:endParaRPr lang="en-US"/>
           </a:p>
         </p:txBody>
       </p:sp>
@@ -1788,7 +2489,7 @@
           <a:p>
             <a:fld id="{5BCAD085-E8A6-8845-BD4E-CB4CCA059FC4}" type="datetimeFigureOut">
               <a:rPr lang="en-US" smtClean="0"/>
-              <a:t>1/27/13</a:t>
+              <a:t>3/23/26</a:t>
             </a:fld>
             <a:endParaRPr lang="en-US"/>
           </a:p>
@@ -1882,10 +2583,9 @@
           <a:lstStyle/>
           <a:p>
             <a:r>
-              <a:rPr lang="en-US" smtClean="0"/>
+              <a:rPr lang="en-US"/>
               <a:t>Click to edit Master title style</a:t>
             </a:r>
-            <a:endParaRPr lang="en-US"/>
           </a:p>
         </p:txBody>
       </p:sp>
@@ -1906,7 +2606,7 @@
           <a:p>
             <a:fld id="{5BCAD085-E8A6-8845-BD4E-CB4CCA059FC4}" type="datetimeFigureOut">
               <a:rPr lang="en-US" smtClean="0"/>
-              <a:t>1/27/13</a:t>
+              <a:t>3/23/26</a:t>
             </a:fld>
             <a:endParaRPr lang="en-US"/>
           </a:p>
@@ -2001,7 +2701,7 @@
           <a:p>
             <a:fld id="{5BCAD085-E8A6-8845-BD4E-CB4CCA059FC4}" type="datetimeFigureOut">
               <a:rPr lang="en-US" smtClean="0"/>
-              <a:t>1/27/13</a:t>
+              <a:t>3/23/26</a:t>
             </a:fld>
             <a:endParaRPr lang="en-US"/>
           </a:p>
@@ -2104,10 +2804,9 @@
           </a:lstStyle>
           <a:p>
             <a:r>
-              <a:rPr lang="en-US" smtClean="0"/>
+              <a:rPr lang="en-US"/>
               <a:t>Click to edit Master title style</a:t>
             </a:r>
-            <a:endParaRPr lang="en-US"/>
           </a:p>
         </p:txBody>
       </p:sp>
@@ -2161,38 +2860,37 @@
           <a:p>
             <a:pPr lvl="0"/>
             <a:r>
-              <a:rPr lang="en-US" smtClean="0"/>
+              <a:rPr lang="en-US"/>
               <a:t>Click to edit Master text styles</a:t>
             </a:r>
           </a:p>
           <a:p>
             <a:pPr lvl="1"/>
             <a:r>
-              <a:rPr lang="en-US" smtClean="0"/>
+              <a:rPr lang="en-US"/>
               <a:t>Second level</a:t>
             </a:r>
           </a:p>
           <a:p>
             <a:pPr lvl="2"/>
             <a:r>
-              <a:rPr lang="en-US" smtClean="0"/>
+              <a:rPr lang="en-US"/>
               <a:t>Third level</a:t>
             </a:r>
           </a:p>
           <a:p>
             <a:pPr lvl="3"/>
             <a:r>
-              <a:rPr lang="en-US" smtClean="0"/>
+              <a:rPr lang="en-US"/>
               <a:t>Fourth level</a:t>
             </a:r>
           </a:p>
           <a:p>
             <a:pPr lvl="4"/>
             <a:r>
-              <a:rPr lang="en-US" smtClean="0"/>
+              <a:rPr lang="en-US"/>
               <a:t>Fifth level</a:t>
             </a:r>
-            <a:endParaRPr lang="en-US"/>
           </a:p>
         </p:txBody>
       </p:sp>
@@ -2255,7 +2953,7 @@
           <a:p>
             <a:pPr lvl="0"/>
             <a:r>
-              <a:rPr lang="en-US" smtClean="0"/>
+              <a:rPr lang="en-US"/>
               <a:t>Click to edit Master text styles</a:t>
             </a:r>
           </a:p>
@@ -2278,7 +2976,7 @@
           <a:p>
             <a:fld id="{5BCAD085-E8A6-8845-BD4E-CB4CCA059FC4}" type="datetimeFigureOut">
               <a:rPr lang="en-US" smtClean="0"/>
-              <a:t>1/27/13</a:t>
+              <a:t>3/23/26</a:t>
             </a:fld>
             <a:endParaRPr lang="en-US"/>
           </a:p>
@@ -2381,10 +3079,9 @@
           </a:lstStyle>
           <a:p>
             <a:r>
-              <a:rPr lang="en-US" smtClean="0"/>
+              <a:rPr lang="en-US"/>
               <a:t>Click to edit Master title style</a:t>
             </a:r>
-            <a:endParaRPr lang="en-US"/>
           </a:p>
         </p:txBody>
       </p:sp>
@@ -2508,7 +3205,7 @@
           <a:p>
             <a:pPr lvl="0"/>
             <a:r>
-              <a:rPr lang="en-US" smtClean="0"/>
+              <a:rPr lang="en-US"/>
               <a:t>Click to edit Master text styles</a:t>
             </a:r>
           </a:p>
@@ -2531,7 +3228,7 @@
           <a:p>
             <a:fld id="{5BCAD085-E8A6-8845-BD4E-CB4CCA059FC4}" type="datetimeFigureOut">
               <a:rPr lang="en-US" smtClean="0"/>
-              <a:t>1/27/13</a:t>
+              <a:t>3/23/26</a:t>
             </a:fld>
             <a:endParaRPr lang="en-US"/>
           </a:p>
@@ -2640,10 +3337,9 @@
           <a:lstStyle/>
           <a:p>
             <a:r>
-              <a:rPr lang="en-US" smtClean="0"/>
+              <a:rPr lang="en-US"/>
               <a:t>Click to edit Master title style</a:t>
             </a:r>
-            <a:endParaRPr lang="en-US"/>
           </a:p>
         </p:txBody>
       </p:sp>
@@ -2674,38 +3370,37 @@
           <a:p>
             <a:pPr lvl="0"/>
             <a:r>
-              <a:rPr lang="en-US" smtClean="0"/>
+              <a:rPr lang="en-US"/>
               <a:t>Click to edit Master text styles</a:t>
             </a:r>
           </a:p>
           <a:p>
             <a:pPr lvl="1"/>
             <a:r>
-              <a:rPr lang="en-US" smtClean="0"/>
+              <a:rPr lang="en-US"/>
               <a:t>Second level</a:t>
             </a:r>
           </a:p>
           <a:p>
             <a:pPr lvl="2"/>
             <a:r>
-              <a:rPr lang="en-US" smtClean="0"/>
+              <a:rPr lang="en-US"/>
               <a:t>Third level</a:t>
             </a:r>
           </a:p>
           <a:p>
             <a:pPr lvl="3"/>
             <a:r>
-              <a:rPr lang="en-US" smtClean="0"/>
+              <a:rPr lang="en-US"/>
               <a:t>Fourth level</a:t>
             </a:r>
           </a:p>
           <a:p>
             <a:pPr lvl="4"/>
             <a:r>
-              <a:rPr lang="en-US" smtClean="0"/>
+              <a:rPr lang="en-US"/>
               <a:t>Fifth level</a:t>
             </a:r>
-            <a:endParaRPr lang="en-US"/>
           </a:p>
         </p:txBody>
       </p:sp>
@@ -2744,7 +3439,7 @@
           <a:p>
             <a:fld id="{5BCAD085-E8A6-8845-BD4E-CB4CCA059FC4}" type="datetimeFigureOut">
               <a:rPr lang="en-US" smtClean="0"/>
-              <a:t>1/27/13</a:t>
+              <a:t>3/23/26</a:t>
             </a:fld>
             <a:endParaRPr lang="en-US"/>
           </a:p>
@@ -2848,6 +3543,7 @@
     <p:sldLayoutId id="2147483657" r:id="rId9"/>
     <p:sldLayoutId id="2147483658" r:id="rId10"/>
     <p:sldLayoutId id="2147483659" r:id="rId11"/>
+    <p:sldLayoutId id="2147483660" r:id="rId12"/>
   </p:sldLayoutIdLst>
   <p:txStyles>
     <p:titleStyle>
@@ -3103,7 +3799,7 @@
 </file>
 
 <file path=ppt/slides/slide1.xml><?xml version="1.0" encoding="utf-8"?>
-<p:sld xmlns:a="http://schemas.openxmlformats.org/drawingml/2006/main" xmlns:p="http://schemas.openxmlformats.org/presentationml/2006/main" xmlns:r="http://schemas.openxmlformats.org/officeDocument/2006/relationships">
+<p:sld xmlns:a="http://schemas.openxmlformats.org/drawingml/2006/main" xmlns:r="http://schemas.openxmlformats.org/officeDocument/2006/relationships" xmlns:p="http://schemas.openxmlformats.org/presentationml/2006/main">
   <p:cSld>
     <p:spTree>
       <p:nvGrpSpPr>
@@ -3111,7 +3807,14 @@
         <p:cNvGrpSpPr/>
         <p:nvPr/>
       </p:nvGrpSpPr>
-      <p:grpSpPr/>
+      <p:grpSpPr>
+        <a:xfrm>
+          <a:off x="0" y="0"/>
+          <a:ext cx="0" cy="0"/>
+          <a:chOff x="0" y="0"/>
+          <a:chExt cx="0" cy="0"/>
+        </a:xfrm>
+      </p:grpSpPr>
       <p:pic>
         <p:nvPicPr>
           <p:cNvPr id="2" name="Picture 1" descr="slide_01.png"/>
@@ -3145,7 +3848,7 @@
 </file>
 
 <file path=ppt/slides/slide10.xml><?xml version="1.0" encoding="utf-8"?>
-<p:sld xmlns:a="http://schemas.openxmlformats.org/drawingml/2006/main" xmlns:p="http://schemas.openxmlformats.org/presentationml/2006/main" xmlns:r="http://schemas.openxmlformats.org/officeDocument/2006/relationships">
+<p:sld xmlns:a="http://schemas.openxmlformats.org/drawingml/2006/main" xmlns:r="http://schemas.openxmlformats.org/officeDocument/2006/relationships" xmlns:p="http://schemas.openxmlformats.org/presentationml/2006/main">
   <p:cSld>
     <p:spTree>
       <p:nvGrpSpPr>
@@ -3153,7 +3856,63 @@
         <p:cNvGrpSpPr/>
         <p:nvPr/>
       </p:nvGrpSpPr>
-      <p:grpSpPr/>
+      <p:grpSpPr>
+        <a:xfrm>
+          <a:off x="0" y="0"/>
+          <a:ext cx="0" cy="0"/>
+          <a:chOff x="0" y="0"/>
+          <a:chExt cx="0" cy="0"/>
+        </a:xfrm>
+      </p:grpSpPr>
+      <p:pic>
+        <p:nvPicPr>
+          <p:cNvPr id="2" name="Picture 1" descr="slide_09.png"/>
+          <p:cNvPicPr>
+            <a:picLocks noChangeAspect="1"/>
+          </p:cNvPicPr>
+          <p:nvPr/>
+        </p:nvPicPr>
+        <p:blipFill>
+          <a:blip r:embed="rId2"/>
+          <a:stretch>
+            <a:fillRect/>
+          </a:stretch>
+        </p:blipFill>
+        <p:spPr>
+          <a:xfrm>
+            <a:off x="0" y="0"/>
+            <a:ext cx="12191695" cy="6858000"/>
+          </a:xfrm>
+          <a:prstGeom prst="rect">
+            <a:avLst/>
+          </a:prstGeom>
+        </p:spPr>
+      </p:pic>
+    </p:spTree>
+  </p:cSld>
+  <p:clrMapOvr>
+    <a:masterClrMapping/>
+  </p:clrMapOvr>
+</p:sld>
+</file>
+
+<file path=ppt/slides/slide11.xml><?xml version="1.0" encoding="utf-8"?>
+<p:sld xmlns:a="http://schemas.openxmlformats.org/drawingml/2006/main" xmlns:r="http://schemas.openxmlformats.org/officeDocument/2006/relationships" xmlns:p="http://schemas.openxmlformats.org/presentationml/2006/main">
+  <p:cSld>
+    <p:spTree>
+      <p:nvGrpSpPr>
+        <p:cNvPr id="1" name=""/>
+        <p:cNvGrpSpPr/>
+        <p:nvPr/>
+      </p:nvGrpSpPr>
+      <p:grpSpPr>
+        <a:xfrm>
+          <a:off x="0" y="0"/>
+          <a:ext cx="0" cy="0"/>
+          <a:chOff x="0" y="0"/>
+          <a:chExt cx="0" cy="0"/>
+        </a:xfrm>
+      </p:grpSpPr>
       <p:pic>
         <p:nvPicPr>
           <p:cNvPr id="2" name="Picture 1" descr="slide_10.png"/>
@@ -3186,8 +3945,8 @@
 </p:sld>
 </file>
 
-<file path=ppt/slides/slide11.xml><?xml version="1.0" encoding="utf-8"?>
-<p:sld xmlns:a="http://schemas.openxmlformats.org/drawingml/2006/main" xmlns:p="http://schemas.openxmlformats.org/presentationml/2006/main" xmlns:r="http://schemas.openxmlformats.org/officeDocument/2006/relationships">
+<file path=ppt/slides/slide12.xml><?xml version="1.0" encoding="utf-8"?>
+<p:sld xmlns:a="http://schemas.openxmlformats.org/drawingml/2006/main" xmlns:r="http://schemas.openxmlformats.org/officeDocument/2006/relationships" xmlns:p="http://schemas.openxmlformats.org/presentationml/2006/main">
   <p:cSld>
     <p:spTree>
       <p:nvGrpSpPr>
@@ -3195,7 +3954,14 @@
         <p:cNvGrpSpPr/>
         <p:nvPr/>
       </p:nvGrpSpPr>
-      <p:grpSpPr/>
+      <p:grpSpPr>
+        <a:xfrm>
+          <a:off x="0" y="0"/>
+          <a:ext cx="0" cy="0"/>
+          <a:chOff x="0" y="0"/>
+          <a:chExt cx="0" cy="0"/>
+        </a:xfrm>
+      </p:grpSpPr>
       <p:pic>
         <p:nvPicPr>
           <p:cNvPr id="2" name="Picture 1" descr="slide_11.png"/>
@@ -3228,8 +3994,8 @@
 </p:sld>
 </file>
 
-<file path=ppt/slides/slide12.xml><?xml version="1.0" encoding="utf-8"?>
-<p:sld xmlns:a="http://schemas.openxmlformats.org/drawingml/2006/main" xmlns:p="http://schemas.openxmlformats.org/presentationml/2006/main" xmlns:r="http://schemas.openxmlformats.org/officeDocument/2006/relationships">
+<file path=ppt/slides/slide13.xml><?xml version="1.0" encoding="utf-8"?>
+<p:sld xmlns:a="http://schemas.openxmlformats.org/drawingml/2006/main" xmlns:r="http://schemas.openxmlformats.org/officeDocument/2006/relationships" xmlns:p="http://schemas.openxmlformats.org/presentationml/2006/main">
   <p:cSld>
     <p:spTree>
       <p:nvGrpSpPr>
@@ -3237,7 +4003,14 @@
         <p:cNvGrpSpPr/>
         <p:nvPr/>
       </p:nvGrpSpPr>
-      <p:grpSpPr/>
+      <p:grpSpPr>
+        <a:xfrm>
+          <a:off x="0" y="0"/>
+          <a:ext cx="0" cy="0"/>
+          <a:chOff x="0" y="0"/>
+          <a:chExt cx="0" cy="0"/>
+        </a:xfrm>
+      </p:grpSpPr>
       <p:pic>
         <p:nvPicPr>
           <p:cNvPr id="2" name="Picture 1" descr="slide_12.png"/>
@@ -3270,8 +4043,8 @@
 </p:sld>
 </file>
 
-<file path=ppt/slides/slide13.xml><?xml version="1.0" encoding="utf-8"?>
-<p:sld xmlns:a="http://schemas.openxmlformats.org/drawingml/2006/main" xmlns:p="http://schemas.openxmlformats.org/presentationml/2006/main" xmlns:r="http://schemas.openxmlformats.org/officeDocument/2006/relationships">
+<file path=ppt/slides/slide14.xml><?xml version="1.0" encoding="utf-8"?>
+<p:sld xmlns:a="http://schemas.openxmlformats.org/drawingml/2006/main" xmlns:r="http://schemas.openxmlformats.org/officeDocument/2006/relationships" xmlns:p="http://schemas.openxmlformats.org/presentationml/2006/main">
   <p:cSld>
     <p:spTree>
       <p:nvGrpSpPr>
@@ -3279,7 +4052,14 @@
         <p:cNvGrpSpPr/>
         <p:nvPr/>
       </p:nvGrpSpPr>
-      <p:grpSpPr/>
+      <p:grpSpPr>
+        <a:xfrm>
+          <a:off x="0" y="0"/>
+          <a:ext cx="0" cy="0"/>
+          <a:chOff x="0" y="0"/>
+          <a:chExt cx="0" cy="0"/>
+        </a:xfrm>
+      </p:grpSpPr>
       <p:pic>
         <p:nvPicPr>
           <p:cNvPr id="2" name="Picture 1" descr="slide_13.png"/>
@@ -3312,8 +4092,8 @@
 </p:sld>
 </file>
 
-<file path=ppt/slides/slide14.xml><?xml version="1.0" encoding="utf-8"?>
-<p:sld xmlns:a="http://schemas.openxmlformats.org/drawingml/2006/main" xmlns:p="http://schemas.openxmlformats.org/presentationml/2006/main" xmlns:r="http://schemas.openxmlformats.org/officeDocument/2006/relationships">
+<file path=ppt/slides/slide15.xml><?xml version="1.0" encoding="utf-8"?>
+<p:sld xmlns:a="http://schemas.openxmlformats.org/drawingml/2006/main" xmlns:r="http://schemas.openxmlformats.org/officeDocument/2006/relationships" xmlns:p="http://schemas.openxmlformats.org/presentationml/2006/main">
   <p:cSld>
     <p:spTree>
       <p:nvGrpSpPr>
@@ -3321,7 +4101,14 @@
         <p:cNvGrpSpPr/>
         <p:nvPr/>
       </p:nvGrpSpPr>
-      <p:grpSpPr/>
+      <p:grpSpPr>
+        <a:xfrm>
+          <a:off x="0" y="0"/>
+          <a:ext cx="0" cy="0"/>
+          <a:chOff x="0" y="0"/>
+          <a:chExt cx="0" cy="0"/>
+        </a:xfrm>
+      </p:grpSpPr>
       <p:pic>
         <p:nvPicPr>
           <p:cNvPr id="2" name="Picture 1" descr="slide_14.png"/>
@@ -3354,8 +4141,8 @@
 </p:sld>
 </file>
 
-<file path=ppt/slides/slide15.xml><?xml version="1.0" encoding="utf-8"?>
-<p:sld xmlns:a="http://schemas.openxmlformats.org/drawingml/2006/main" xmlns:p="http://schemas.openxmlformats.org/presentationml/2006/main" xmlns:r="http://schemas.openxmlformats.org/officeDocument/2006/relationships">
+<file path=ppt/slides/slide16.xml><?xml version="1.0" encoding="utf-8"?>
+<p:sld xmlns:a="http://schemas.openxmlformats.org/drawingml/2006/main" xmlns:r="http://schemas.openxmlformats.org/officeDocument/2006/relationships" xmlns:p="http://schemas.openxmlformats.org/presentationml/2006/main">
   <p:cSld>
     <p:spTree>
       <p:nvGrpSpPr>
@@ -3363,7 +4150,14 @@
         <p:cNvGrpSpPr/>
         <p:nvPr/>
       </p:nvGrpSpPr>
-      <p:grpSpPr/>
+      <p:grpSpPr>
+        <a:xfrm>
+          <a:off x="0" y="0"/>
+          <a:ext cx="0" cy="0"/>
+          <a:chOff x="0" y="0"/>
+          <a:chExt cx="0" cy="0"/>
+        </a:xfrm>
+      </p:grpSpPr>
       <p:pic>
         <p:nvPicPr>
           <p:cNvPr id="2" name="Picture 1" descr="slide_15.png"/>
@@ -3396,8 +4190,8 @@
 </p:sld>
 </file>
 
-<file path=ppt/slides/slide16.xml><?xml version="1.0" encoding="utf-8"?>
-<p:sld xmlns:a="http://schemas.openxmlformats.org/drawingml/2006/main" xmlns:p="http://schemas.openxmlformats.org/presentationml/2006/main" xmlns:r="http://schemas.openxmlformats.org/officeDocument/2006/relationships">
+<file path=ppt/slides/slide17.xml><?xml version="1.0" encoding="utf-8"?>
+<p:sld xmlns:a="http://schemas.openxmlformats.org/drawingml/2006/main" xmlns:r="http://schemas.openxmlformats.org/officeDocument/2006/relationships" xmlns:p="http://schemas.openxmlformats.org/presentationml/2006/main">
   <p:cSld>
     <p:spTree>
       <p:nvGrpSpPr>
@@ -3405,7 +4199,14 @@
         <p:cNvGrpSpPr/>
         <p:nvPr/>
       </p:nvGrpSpPr>
-      <p:grpSpPr/>
+      <p:grpSpPr>
+        <a:xfrm>
+          <a:off x="0" y="0"/>
+          <a:ext cx="0" cy="0"/>
+          <a:chOff x="0" y="0"/>
+          <a:chExt cx="0" cy="0"/>
+        </a:xfrm>
+      </p:grpSpPr>
       <p:pic>
         <p:nvPicPr>
           <p:cNvPr id="2" name="Picture 1" descr="slide_16.png"/>
@@ -3438,8 +4239,8 @@
 </p:sld>
 </file>
 
-<file path=ppt/slides/slide17.xml><?xml version="1.0" encoding="utf-8"?>
-<p:sld xmlns:a="http://schemas.openxmlformats.org/drawingml/2006/main" xmlns:p="http://schemas.openxmlformats.org/presentationml/2006/main" xmlns:r="http://schemas.openxmlformats.org/officeDocument/2006/relationships">
+<file path=ppt/slides/slide18.xml><?xml version="1.0" encoding="utf-8"?>
+<p:sld xmlns:a="http://schemas.openxmlformats.org/drawingml/2006/main" xmlns:r="http://schemas.openxmlformats.org/officeDocument/2006/relationships" xmlns:p="http://schemas.openxmlformats.org/presentationml/2006/main">
   <p:cSld>
     <p:spTree>
       <p:nvGrpSpPr>
@@ -3447,7 +4248,14 @@
         <p:cNvGrpSpPr/>
         <p:nvPr/>
       </p:nvGrpSpPr>
-      <p:grpSpPr/>
+      <p:grpSpPr>
+        <a:xfrm>
+          <a:off x="0" y="0"/>
+          <a:ext cx="0" cy="0"/>
+          <a:chOff x="0" y="0"/>
+          <a:chExt cx="0" cy="0"/>
+        </a:xfrm>
+      </p:grpSpPr>
       <p:pic>
         <p:nvPicPr>
           <p:cNvPr id="2" name="Picture 1" descr="slide_17.png"/>
@@ -3480,8 +4288,8 @@
 </p:sld>
 </file>
 
-<file path=ppt/slides/slide18.xml><?xml version="1.0" encoding="utf-8"?>
-<p:sld xmlns:a="http://schemas.openxmlformats.org/drawingml/2006/main" xmlns:p="http://schemas.openxmlformats.org/presentationml/2006/main" xmlns:r="http://schemas.openxmlformats.org/officeDocument/2006/relationships">
+<file path=ppt/slides/slide19.xml><?xml version="1.0" encoding="utf-8"?>
+<p:sld xmlns:a="http://schemas.openxmlformats.org/drawingml/2006/main" xmlns:r="http://schemas.openxmlformats.org/officeDocument/2006/relationships" xmlns:p="http://schemas.openxmlformats.org/presentationml/2006/main">
   <p:cSld>
     <p:spTree>
       <p:nvGrpSpPr>
@@ -3489,7 +4297,14 @@
         <p:cNvGrpSpPr/>
         <p:nvPr/>
       </p:nvGrpSpPr>
-      <p:grpSpPr/>
+      <p:grpSpPr>
+        <a:xfrm>
+          <a:off x="0" y="0"/>
+          <a:ext cx="0" cy="0"/>
+          <a:chOff x="0" y="0"/>
+          <a:chExt cx="0" cy="0"/>
+        </a:xfrm>
+      </p:grpSpPr>
       <p:pic>
         <p:nvPicPr>
           <p:cNvPr id="2" name="Picture 1" descr="slide_18.png"/>
@@ -3522,8 +4337,8 @@
 </p:sld>
 </file>
 
-<file path=ppt/slides/slide19.xml><?xml version="1.0" encoding="utf-8"?>
-<p:sld xmlns:a="http://schemas.openxmlformats.org/drawingml/2006/main" xmlns:p="http://schemas.openxmlformats.org/presentationml/2006/main" xmlns:r="http://schemas.openxmlformats.org/officeDocument/2006/relationships">
+<file path=ppt/slides/slide2.xml><?xml version="1.0" encoding="utf-8"?>
+<p:sld xmlns:a="http://schemas.openxmlformats.org/drawingml/2006/main" xmlns:r="http://schemas.openxmlformats.org/officeDocument/2006/relationships" xmlns:p="http://schemas.openxmlformats.org/presentationml/2006/main">
   <p:cSld>
     <p:spTree>
       <p:nvGrpSpPr>
@@ -3531,7 +4346,63 @@
         <p:cNvGrpSpPr/>
         <p:nvPr/>
       </p:nvGrpSpPr>
-      <p:grpSpPr/>
+      <p:grpSpPr>
+        <a:xfrm>
+          <a:off x="0" y="0"/>
+          <a:ext cx="0" cy="0"/>
+          <a:chOff x="0" y="0"/>
+          <a:chExt cx="0" cy="0"/>
+        </a:xfrm>
+      </p:grpSpPr>
+      <p:pic>
+        <p:nvPicPr>
+          <p:cNvPr id="2" name="Picture 1" descr="slide_02.png"/>
+          <p:cNvPicPr>
+            <a:picLocks noChangeAspect="1"/>
+          </p:cNvPicPr>
+          <p:nvPr/>
+        </p:nvPicPr>
+        <p:blipFill>
+          <a:blip r:embed="rId2"/>
+          <a:stretch>
+            <a:fillRect/>
+          </a:stretch>
+        </p:blipFill>
+        <p:spPr>
+          <a:xfrm>
+            <a:off x="0" y="0"/>
+            <a:ext cx="12191695" cy="6858000"/>
+          </a:xfrm>
+          <a:prstGeom prst="rect">
+            <a:avLst/>
+          </a:prstGeom>
+        </p:spPr>
+      </p:pic>
+    </p:spTree>
+  </p:cSld>
+  <p:clrMapOvr>
+    <a:masterClrMapping/>
+  </p:clrMapOvr>
+</p:sld>
+</file>
+
+<file path=ppt/slides/slide20.xml><?xml version="1.0" encoding="utf-8"?>
+<p:sld xmlns:a="http://schemas.openxmlformats.org/drawingml/2006/main" xmlns:r="http://schemas.openxmlformats.org/officeDocument/2006/relationships" xmlns:p="http://schemas.openxmlformats.org/presentationml/2006/main">
+  <p:cSld>
+    <p:spTree>
+      <p:nvGrpSpPr>
+        <p:cNvPr id="1" name=""/>
+        <p:cNvGrpSpPr/>
+        <p:nvPr/>
+      </p:nvGrpSpPr>
+      <p:grpSpPr>
+        <a:xfrm>
+          <a:off x="0" y="0"/>
+          <a:ext cx="0" cy="0"/>
+          <a:chOff x="0" y="0"/>
+          <a:chExt cx="0" cy="0"/>
+        </a:xfrm>
+      </p:grpSpPr>
       <p:pic>
         <p:nvPicPr>
           <p:cNvPr id="2" name="Picture 1" descr="slide_19.png"/>
@@ -3564,8 +4435,8 @@
 </p:sld>
 </file>
 
-<file path=ppt/slides/slide2.xml><?xml version="1.0" encoding="utf-8"?>
-<p:sld xmlns:a="http://schemas.openxmlformats.org/drawingml/2006/main" xmlns:p="http://schemas.openxmlformats.org/presentationml/2006/main" xmlns:r="http://schemas.openxmlformats.org/officeDocument/2006/relationships">
+<file path=ppt/slides/slide21.xml><?xml version="1.0" encoding="utf-8"?>
+<p:sld xmlns:a="http://schemas.openxmlformats.org/drawingml/2006/main" xmlns:r="http://schemas.openxmlformats.org/officeDocument/2006/relationships" xmlns:p="http://schemas.openxmlformats.org/presentationml/2006/main">
   <p:cSld>
     <p:spTree>
       <p:nvGrpSpPr>
@@ -3573,49 +4444,14 @@
         <p:cNvGrpSpPr/>
         <p:nvPr/>
       </p:nvGrpSpPr>
-      <p:grpSpPr/>
-      <p:pic>
-        <p:nvPicPr>
-          <p:cNvPr id="2" name="Picture 1" descr="slide_02.png"/>
-          <p:cNvPicPr>
-            <a:picLocks noChangeAspect="1"/>
-          </p:cNvPicPr>
-          <p:nvPr/>
-        </p:nvPicPr>
-        <p:blipFill>
-          <a:blip r:embed="rId2"/>
-          <a:stretch>
-            <a:fillRect/>
-          </a:stretch>
-        </p:blipFill>
-        <p:spPr>
-          <a:xfrm>
-            <a:off x="0" y="0"/>
-            <a:ext cx="12191695" cy="6858000"/>
-          </a:xfrm>
-          <a:prstGeom prst="rect">
-            <a:avLst/>
-          </a:prstGeom>
-        </p:spPr>
-      </p:pic>
-    </p:spTree>
-  </p:cSld>
-  <p:clrMapOvr>
-    <a:masterClrMapping/>
-  </p:clrMapOvr>
-</p:sld>
-</file>
-
-<file path=ppt/slides/slide20.xml><?xml version="1.0" encoding="utf-8"?>
-<p:sld xmlns:a="http://schemas.openxmlformats.org/drawingml/2006/main" xmlns:p="http://schemas.openxmlformats.org/presentationml/2006/main" xmlns:r="http://schemas.openxmlformats.org/officeDocument/2006/relationships">
-  <p:cSld>
-    <p:spTree>
-      <p:nvGrpSpPr>
-        <p:cNvPr id="1" name=""/>
-        <p:cNvGrpSpPr/>
-        <p:nvPr/>
-      </p:nvGrpSpPr>
-      <p:grpSpPr/>
+      <p:grpSpPr>
+        <a:xfrm>
+          <a:off x="0" y="0"/>
+          <a:ext cx="0" cy="0"/>
+          <a:chOff x="0" y="0"/>
+          <a:chExt cx="0" cy="0"/>
+        </a:xfrm>
+      </p:grpSpPr>
       <p:pic>
         <p:nvPicPr>
           <p:cNvPr id="2" name="Picture 1" descr="slide_20.png"/>
@@ -3648,8 +4484,8 @@
 </p:sld>
 </file>
 
-<file path=ppt/slides/slide21.xml><?xml version="1.0" encoding="utf-8"?>
-<p:sld xmlns:a="http://schemas.openxmlformats.org/drawingml/2006/main" xmlns:p="http://schemas.openxmlformats.org/presentationml/2006/main" xmlns:r="http://schemas.openxmlformats.org/officeDocument/2006/relationships">
+<file path=ppt/slides/slide22.xml><?xml version="1.0" encoding="utf-8"?>
+<p:sld xmlns:a="http://schemas.openxmlformats.org/drawingml/2006/main" xmlns:r="http://schemas.openxmlformats.org/officeDocument/2006/relationships" xmlns:p="http://schemas.openxmlformats.org/presentationml/2006/main">
   <p:cSld>
     <p:spTree>
       <p:nvGrpSpPr>
@@ -3657,7 +4493,14 @@
         <p:cNvGrpSpPr/>
         <p:nvPr/>
       </p:nvGrpSpPr>
-      <p:grpSpPr/>
+      <p:grpSpPr>
+        <a:xfrm>
+          <a:off x="0" y="0"/>
+          <a:ext cx="0" cy="0"/>
+          <a:chOff x="0" y="0"/>
+          <a:chExt cx="0" cy="0"/>
+        </a:xfrm>
+      </p:grpSpPr>
       <p:pic>
         <p:nvPicPr>
           <p:cNvPr id="2" name="Picture 1" descr="slide_21.png"/>
@@ -3690,8 +4533,8 @@
 </p:sld>
 </file>
 
-<file path=ppt/slides/slide22.xml><?xml version="1.0" encoding="utf-8"?>
-<p:sld xmlns:a="http://schemas.openxmlformats.org/drawingml/2006/main" xmlns:p="http://schemas.openxmlformats.org/presentationml/2006/main" xmlns:r="http://schemas.openxmlformats.org/officeDocument/2006/relationships">
+<file path=ppt/slides/slide23.xml><?xml version="1.0" encoding="utf-8"?>
+<p:sld xmlns:a="http://schemas.openxmlformats.org/drawingml/2006/main" xmlns:r="http://schemas.openxmlformats.org/officeDocument/2006/relationships" xmlns:p="http://schemas.openxmlformats.org/presentationml/2006/main">
   <p:cSld>
     <p:spTree>
       <p:nvGrpSpPr>
@@ -3699,7 +4542,14 @@
         <p:cNvGrpSpPr/>
         <p:nvPr/>
       </p:nvGrpSpPr>
-      <p:grpSpPr/>
+      <p:grpSpPr>
+        <a:xfrm>
+          <a:off x="0" y="0"/>
+          <a:ext cx="0" cy="0"/>
+          <a:chOff x="0" y="0"/>
+          <a:chExt cx="0" cy="0"/>
+        </a:xfrm>
+      </p:grpSpPr>
       <p:pic>
         <p:nvPicPr>
           <p:cNvPr id="2" name="Picture 1" descr="slide_22.png"/>
@@ -3732,8 +4582,8 @@
 </p:sld>
 </file>
 
-<file path=ppt/slides/slide23.xml><?xml version="1.0" encoding="utf-8"?>
-<p:sld xmlns:a="http://schemas.openxmlformats.org/drawingml/2006/main" xmlns:p="http://schemas.openxmlformats.org/presentationml/2006/main" xmlns:r="http://schemas.openxmlformats.org/officeDocument/2006/relationships">
+<file path=ppt/slides/slide24.xml><?xml version="1.0" encoding="utf-8"?>
+<p:sld xmlns:a="http://schemas.openxmlformats.org/drawingml/2006/main" xmlns:r="http://schemas.openxmlformats.org/officeDocument/2006/relationships" xmlns:p="http://schemas.openxmlformats.org/presentationml/2006/main">
   <p:cSld>
     <p:spTree>
       <p:nvGrpSpPr>
@@ -3741,7 +4591,14 @@
         <p:cNvGrpSpPr/>
         <p:nvPr/>
       </p:nvGrpSpPr>
-      <p:grpSpPr/>
+      <p:grpSpPr>
+        <a:xfrm>
+          <a:off x="0" y="0"/>
+          <a:ext cx="0" cy="0"/>
+          <a:chOff x="0" y="0"/>
+          <a:chExt cx="0" cy="0"/>
+        </a:xfrm>
+      </p:grpSpPr>
       <p:pic>
         <p:nvPicPr>
           <p:cNvPr id="2" name="Picture 1" descr="slide_23.png"/>
@@ -3774,8 +4631,8 @@
 </p:sld>
 </file>
 
-<file path=ppt/slides/slide24.xml><?xml version="1.0" encoding="utf-8"?>
-<p:sld xmlns:a="http://schemas.openxmlformats.org/drawingml/2006/main" xmlns:p="http://schemas.openxmlformats.org/presentationml/2006/main" xmlns:r="http://schemas.openxmlformats.org/officeDocument/2006/relationships">
+<file path=ppt/slides/slide25.xml><?xml version="1.0" encoding="utf-8"?>
+<p:sld xmlns:a="http://schemas.openxmlformats.org/drawingml/2006/main" xmlns:r="http://schemas.openxmlformats.org/officeDocument/2006/relationships" xmlns:p="http://schemas.openxmlformats.org/presentationml/2006/main">
   <p:cSld>
     <p:spTree>
       <p:nvGrpSpPr>
@@ -3783,7 +4640,14 @@
         <p:cNvGrpSpPr/>
         <p:nvPr/>
       </p:nvGrpSpPr>
-      <p:grpSpPr/>
+      <p:grpSpPr>
+        <a:xfrm>
+          <a:off x="0" y="0"/>
+          <a:ext cx="0" cy="0"/>
+          <a:chOff x="0" y="0"/>
+          <a:chExt cx="0" cy="0"/>
+        </a:xfrm>
+      </p:grpSpPr>
       <p:pic>
         <p:nvPicPr>
           <p:cNvPr id="2" name="Picture 1" descr="slide_24.png"/>
@@ -3816,8 +4680,8 @@
 </p:sld>
 </file>
 
-<file path=ppt/slides/slide25.xml><?xml version="1.0" encoding="utf-8"?>
-<p:sld xmlns:a="http://schemas.openxmlformats.org/drawingml/2006/main" xmlns:p="http://schemas.openxmlformats.org/presentationml/2006/main" xmlns:r="http://schemas.openxmlformats.org/officeDocument/2006/relationships">
+<file path=ppt/slides/slide26.xml><?xml version="1.0" encoding="utf-8"?>
+<p:sld xmlns:a="http://schemas.openxmlformats.org/drawingml/2006/main" xmlns:r="http://schemas.openxmlformats.org/officeDocument/2006/relationships" xmlns:p="http://schemas.openxmlformats.org/presentationml/2006/main">
   <p:cSld>
     <p:spTree>
       <p:nvGrpSpPr>
@@ -3825,7 +4689,14 @@
         <p:cNvGrpSpPr/>
         <p:nvPr/>
       </p:nvGrpSpPr>
-      <p:grpSpPr/>
+      <p:grpSpPr>
+        <a:xfrm>
+          <a:off x="0" y="0"/>
+          <a:ext cx="0" cy="0"/>
+          <a:chOff x="0" y="0"/>
+          <a:chExt cx="0" cy="0"/>
+        </a:xfrm>
+      </p:grpSpPr>
       <p:pic>
         <p:nvPicPr>
           <p:cNvPr id="2" name="Picture 1" descr="slide_25.png"/>
@@ -3859,7 +4730,293 @@
 </file>
 
 <file path=ppt/slides/slide3.xml><?xml version="1.0" encoding="utf-8"?>
-<p:sld xmlns:a="http://schemas.openxmlformats.org/drawingml/2006/main" xmlns:p="http://schemas.openxmlformats.org/presentationml/2006/main" xmlns:r="http://schemas.openxmlformats.org/officeDocument/2006/relationships">
+<p:sld xmlns:a="http://schemas.openxmlformats.org/drawingml/2006/main" xmlns:r="http://schemas.openxmlformats.org/officeDocument/2006/relationships" xmlns:p="http://schemas.openxmlformats.org/presentationml/2006/main">
+  <p:cSld>
+    <p:spTree>
+      <p:nvGrpSpPr>
+        <p:cNvPr id="1" name="">
+          <a:extLst>
+            <a:ext uri="{FF2B5EF4-FFF2-40B4-BE49-F238E27FC236}">
+              <a16:creationId xmlns:a16="http://schemas.microsoft.com/office/drawing/2014/main" id="{8EF1EC1B-45C2-FED2-38E5-8855839D978A}"/>
+            </a:ext>
+          </a:extLst>
+        </p:cNvPr>
+        <p:cNvGrpSpPr/>
+        <p:nvPr/>
+      </p:nvGrpSpPr>
+      <p:grpSpPr>
+        <a:xfrm>
+          <a:off x="0" y="0"/>
+          <a:ext cx="0" cy="0"/>
+          <a:chOff x="0" y="0"/>
+          <a:chExt cx="0" cy="0"/>
+        </a:xfrm>
+      </p:grpSpPr>
+      <p:sp>
+        <p:nvSpPr>
+          <p:cNvPr id="4" name="Title 3">
+            <a:extLst>
+              <a:ext uri="{FF2B5EF4-FFF2-40B4-BE49-F238E27FC236}">
+                <a16:creationId xmlns:a16="http://schemas.microsoft.com/office/drawing/2014/main" id="{EF8CE093-1E6C-4B12-8DB8-8A4671BB4E7F}"/>
+              </a:ext>
+            </a:extLst>
+          </p:cNvPr>
+          <p:cNvSpPr txBox="1">
+            <a:spLocks/>
+          </p:cNvSpPr>
+          <p:nvPr/>
+        </p:nvSpPr>
+        <p:spPr>
+          <a:xfrm>
+            <a:off x="518670" y="375698"/>
+            <a:ext cx="10182304" cy="492443"/>
+          </a:xfrm>
+          <a:prstGeom prst="rect">
+            <a:avLst/>
+          </a:prstGeom>
+        </p:spPr>
+        <p:txBody>
+          <a:bodyPr vert="horz" wrap="square" lIns="0" tIns="0" rIns="0" bIns="0" rtlCol="0" anchor="ctr">
+            <a:spAutoFit/>
+          </a:bodyPr>
+          <a:lstStyle>
+            <a:lvl1pPr algn="l" defTabSz="1088291" rtl="0" eaLnBrk="1" latinLnBrk="0" hangingPunct="1">
+              <a:spcBef>
+                <a:spcPct val="0"/>
+              </a:spcBef>
+              <a:buNone/>
+              <a:defRPr sz="3200" b="0" i="0" u="none" kern="1200">
+                <a:solidFill>
+                  <a:schemeClr val="bg1"/>
+                </a:solidFill>
+                <a:latin typeface="Adobe Clean Light" pitchFamily="34" charset="0"/>
+                <a:ea typeface="+mj-ea"/>
+                <a:cs typeface="+mj-cs"/>
+              </a:defRPr>
+            </a:lvl1pPr>
+          </a:lstStyle>
+          <a:p>
+            <a:r>
+              <a:rPr lang="en-US" b="1" dirty="0">
+                <a:solidFill>
+                  <a:srgbClr val="E41000"/>
+                </a:solidFill>
+                <a:latin typeface="Adobe Clean" panose="020B0503020404020204" pitchFamily="34" charset="0"/>
+              </a:rPr>
+              <a:t>Future Potential Scalability</a:t>
+            </a:r>
+          </a:p>
+        </p:txBody>
+      </p:sp>
+      <p:sp>
+        <p:nvSpPr>
+          <p:cNvPr id="7" name="Thread">
+            <a:extLst>
+              <a:ext uri="{FF2B5EF4-FFF2-40B4-BE49-F238E27FC236}">
+                <a16:creationId xmlns:a16="http://schemas.microsoft.com/office/drawing/2014/main" id="{048AE4CD-6C9C-E98D-3D5C-475BE630F402}"/>
+              </a:ext>
+              <a:ext uri="{C183D7F6-B498-43B3-948B-1728B52AA6E4}">
+                <adec:decorative xmlns:adec="http://schemas.microsoft.com/office/drawing/2017/decorative" val="1"/>
+              </a:ext>
+            </a:extLst>
+          </p:cNvPr>
+          <p:cNvSpPr/>
+          <p:nvPr/>
+        </p:nvSpPr>
+        <p:spPr>
+          <a:xfrm>
+            <a:off x="-1" y="895"/>
+            <a:ext cx="110170" cy="6856213"/>
+          </a:xfrm>
+          <a:prstGeom prst="rect">
+            <a:avLst/>
+          </a:prstGeom>
+          <a:solidFill>
+            <a:srgbClr val="EB1000"/>
+          </a:solidFill>
+          <a:ln w="12700">
+            <a:noFill/>
+          </a:ln>
+        </p:spPr>
+        <p:style>
+          <a:lnRef idx="2">
+            <a:schemeClr val="accent1">
+              <a:shade val="50000"/>
+            </a:schemeClr>
+          </a:lnRef>
+          <a:fillRef idx="1">
+            <a:schemeClr val="accent1"/>
+          </a:fillRef>
+          <a:effectRef idx="0">
+            <a:schemeClr val="accent1"/>
+          </a:effectRef>
+          <a:fontRef idx="minor">
+            <a:schemeClr val="lt1"/>
+          </a:fontRef>
+        </p:style>
+        <p:txBody>
+          <a:bodyPr lIns="45708" tIns="45708" rIns="45708" bIns="45708" rtlCol="0" anchor="ctr"/>
+          <a:lstStyle/>
+          <a:p>
+            <a:pPr>
+              <a:spcBef>
+                <a:spcPts val="1200"/>
+              </a:spcBef>
+            </a:pPr>
+            <a:endParaRPr lang="en-US" sz="1400" dirty="0">
+              <a:solidFill>
+                <a:schemeClr val="tx1"/>
+              </a:solidFill>
+            </a:endParaRPr>
+          </a:p>
+        </p:txBody>
+      </p:sp>
+      <p:sp>
+        <p:nvSpPr>
+          <p:cNvPr id="3" name="Rectangle 2">
+            <a:extLst>
+              <a:ext uri="{FF2B5EF4-FFF2-40B4-BE49-F238E27FC236}">
+                <a16:creationId xmlns:a16="http://schemas.microsoft.com/office/drawing/2014/main" id="{6DE177BA-A9EA-C975-E05C-620E214EC6F2}"/>
+              </a:ext>
+            </a:extLst>
+          </p:cNvPr>
+          <p:cNvSpPr/>
+          <p:nvPr/>
+        </p:nvSpPr>
+        <p:spPr>
+          <a:xfrm>
+            <a:off x="10681781" y="2"/>
+            <a:ext cx="1163977" cy="1057300"/>
+          </a:xfrm>
+          <a:prstGeom prst="rect">
+            <a:avLst/>
+          </a:prstGeom>
+          <a:solidFill>
+            <a:schemeClr val="bg1"/>
+          </a:solidFill>
+          <a:ln>
+            <a:noFill/>
+          </a:ln>
+        </p:spPr>
+        <p:style>
+          <a:lnRef idx="2">
+            <a:schemeClr val="accent1">
+              <a:shade val="15000"/>
+            </a:schemeClr>
+          </a:lnRef>
+          <a:fillRef idx="1">
+            <a:schemeClr val="accent1"/>
+          </a:fillRef>
+          <a:effectRef idx="0">
+            <a:schemeClr val="accent1"/>
+          </a:effectRef>
+          <a:fontRef idx="minor">
+            <a:schemeClr val="lt1"/>
+          </a:fontRef>
+        </p:style>
+        <p:txBody>
+          <a:bodyPr rtlCol="0" anchor="ctr"/>
+          <a:lstStyle/>
+          <a:p>
+            <a:pPr algn="ctr"/>
+            <a:endParaRPr lang="en-US" dirty="0"/>
+          </a:p>
+        </p:txBody>
+      </p:sp>
+      <p:sp>
+        <p:nvSpPr>
+          <p:cNvPr id="9" name="Copyright">
+            <a:extLst>
+              <a:ext uri="{FF2B5EF4-FFF2-40B4-BE49-F238E27FC236}">
+                <a16:creationId xmlns:a16="http://schemas.microsoft.com/office/drawing/2014/main" id="{B69E8D9A-0064-4B1E-B323-FED85975A1B2}"/>
+              </a:ext>
+            </a:extLst>
+          </p:cNvPr>
+          <p:cNvSpPr txBox="1"/>
+          <p:nvPr/>
+        </p:nvSpPr>
+        <p:spPr>
+          <a:xfrm>
+            <a:off x="8752396" y="6583682"/>
+            <a:ext cx="2828576" cy="138499"/>
+          </a:xfrm>
+          <a:prstGeom prst="rect">
+            <a:avLst/>
+          </a:prstGeom>
+          <a:noFill/>
+        </p:spPr>
+        <p:txBody>
+          <a:bodyPr wrap="square" lIns="0" tIns="0" rIns="0" bIns="0">
+            <a:spAutoFit/>
+          </a:bodyPr>
+          <a:lstStyle/>
+          <a:p>
+            <a:pPr algn="r" defTabSz="914126">
+              <a:defRPr/>
+            </a:pPr>
+            <a:r>
+              <a:rPr lang="en-US" sz="900" dirty="0">
+                <a:solidFill>
+                  <a:schemeClr val="bg1"/>
+                </a:solidFill>
+                <a:latin typeface="Adobe Clean" panose="020B0503020404020204" pitchFamily="34" charset="0"/>
+              </a:rPr>
+              <a:t>© 2025 Adobe. All Rights Reserved. Adobe Confidential.</a:t>
+            </a:r>
+          </a:p>
+        </p:txBody>
+      </p:sp>
+      <p:sp>
+        <p:nvSpPr>
+          <p:cNvPr id="2" name="TextBox 1">
+            <a:extLst>
+              <a:ext uri="{FF2B5EF4-FFF2-40B4-BE49-F238E27FC236}">
+                <a16:creationId xmlns:a16="http://schemas.microsoft.com/office/drawing/2014/main" id="{0E550A39-AA6B-7299-B7B5-9668FBED745F}"/>
+              </a:ext>
+            </a:extLst>
+          </p:cNvPr>
+          <p:cNvSpPr txBox="1"/>
+          <p:nvPr/>
+        </p:nvSpPr>
+        <p:spPr>
+          <a:xfrm>
+            <a:off x="649995" y="1608463"/>
+            <a:ext cx="9904164" cy="369332"/>
+          </a:xfrm>
+          <a:prstGeom prst="rect">
+            <a:avLst/>
+          </a:prstGeom>
+          <a:noFill/>
+        </p:spPr>
+        <p:txBody>
+          <a:bodyPr wrap="square" rtlCol="0">
+            <a:spAutoFit/>
+          </a:bodyPr>
+          <a:lstStyle/>
+          <a:p>
+            <a:r>
+              <a:rPr lang="en-US" dirty="0" err="1"/>
+              <a:t>asdsad</a:t>
+            </a:r>
+            <a:endParaRPr lang="en-US" dirty="0"/>
+          </a:p>
+        </p:txBody>
+      </p:sp>
+    </p:spTree>
+    <p:extLst>
+      <p:ext uri="{BB962C8B-B14F-4D97-AF65-F5344CB8AC3E}">
+        <p14:creationId xmlns:p14="http://schemas.microsoft.com/office/powerpoint/2010/main" val="1569827241"/>
+      </p:ext>
+    </p:extLst>
+  </p:cSld>
+  <p:clrMapOvr>
+    <a:masterClrMapping/>
+  </p:clrMapOvr>
+</p:sld>
+</file>
+
+<file path=ppt/slides/slide4.xml><?xml version="1.0" encoding="utf-8"?>
+<p:sld xmlns:a="http://schemas.openxmlformats.org/drawingml/2006/main" xmlns:r="http://schemas.openxmlformats.org/officeDocument/2006/relationships" xmlns:p="http://schemas.openxmlformats.org/presentationml/2006/main">
   <p:cSld>
     <p:spTree>
       <p:nvGrpSpPr>
@@ -3867,7 +5024,14 @@
         <p:cNvGrpSpPr/>
         <p:nvPr/>
       </p:nvGrpSpPr>
-      <p:grpSpPr/>
+      <p:grpSpPr>
+        <a:xfrm>
+          <a:off x="0" y="0"/>
+          <a:ext cx="0" cy="0"/>
+          <a:chOff x="0" y="0"/>
+          <a:chExt cx="0" cy="0"/>
+        </a:xfrm>
+      </p:grpSpPr>
       <p:pic>
         <p:nvPicPr>
           <p:cNvPr id="2" name="Picture 1" descr="slide_03.png"/>
@@ -3900,8 +5064,8 @@
 </p:sld>
 </file>
 
-<file path=ppt/slides/slide4.xml><?xml version="1.0" encoding="utf-8"?>
-<p:sld xmlns:a="http://schemas.openxmlformats.org/drawingml/2006/main" xmlns:p="http://schemas.openxmlformats.org/presentationml/2006/main" xmlns:r="http://schemas.openxmlformats.org/officeDocument/2006/relationships">
+<file path=ppt/slides/slide5.xml><?xml version="1.0" encoding="utf-8"?>
+<p:sld xmlns:a="http://schemas.openxmlformats.org/drawingml/2006/main" xmlns:r="http://schemas.openxmlformats.org/officeDocument/2006/relationships" xmlns:p="http://schemas.openxmlformats.org/presentationml/2006/main">
   <p:cSld>
     <p:spTree>
       <p:nvGrpSpPr>
@@ -3909,7 +5073,14 @@
         <p:cNvGrpSpPr/>
         <p:nvPr/>
       </p:nvGrpSpPr>
-      <p:grpSpPr/>
+      <p:grpSpPr>
+        <a:xfrm>
+          <a:off x="0" y="0"/>
+          <a:ext cx="0" cy="0"/>
+          <a:chOff x="0" y="0"/>
+          <a:chExt cx="0" cy="0"/>
+        </a:xfrm>
+      </p:grpSpPr>
       <p:pic>
         <p:nvPicPr>
           <p:cNvPr id="2" name="Picture 1" descr="slide_04.png"/>
@@ -3942,8 +5113,8 @@
 </p:sld>
 </file>
 
-<file path=ppt/slides/slide5.xml><?xml version="1.0" encoding="utf-8"?>
-<p:sld xmlns:a="http://schemas.openxmlformats.org/drawingml/2006/main" xmlns:p="http://schemas.openxmlformats.org/presentationml/2006/main" xmlns:r="http://schemas.openxmlformats.org/officeDocument/2006/relationships">
+<file path=ppt/slides/slide6.xml><?xml version="1.0" encoding="utf-8"?>
+<p:sld xmlns:a="http://schemas.openxmlformats.org/drawingml/2006/main" xmlns:r="http://schemas.openxmlformats.org/officeDocument/2006/relationships" xmlns:p="http://schemas.openxmlformats.org/presentationml/2006/main">
   <p:cSld>
     <p:spTree>
       <p:nvGrpSpPr>
@@ -3951,7 +5122,14 @@
         <p:cNvGrpSpPr/>
         <p:nvPr/>
       </p:nvGrpSpPr>
-      <p:grpSpPr/>
+      <p:grpSpPr>
+        <a:xfrm>
+          <a:off x="0" y="0"/>
+          <a:ext cx="0" cy="0"/>
+          <a:chOff x="0" y="0"/>
+          <a:chExt cx="0" cy="0"/>
+        </a:xfrm>
+      </p:grpSpPr>
       <p:pic>
         <p:nvPicPr>
           <p:cNvPr id="2" name="Picture 1" descr="slide_05.png"/>
@@ -3984,8 +5162,8 @@
 </p:sld>
 </file>
 
-<file path=ppt/slides/slide6.xml><?xml version="1.0" encoding="utf-8"?>
-<p:sld xmlns:a="http://schemas.openxmlformats.org/drawingml/2006/main" xmlns:p="http://schemas.openxmlformats.org/presentationml/2006/main" xmlns:r="http://schemas.openxmlformats.org/officeDocument/2006/relationships">
+<file path=ppt/slides/slide7.xml><?xml version="1.0" encoding="utf-8"?>
+<p:sld xmlns:a="http://schemas.openxmlformats.org/drawingml/2006/main" xmlns:r="http://schemas.openxmlformats.org/officeDocument/2006/relationships" xmlns:p="http://schemas.openxmlformats.org/presentationml/2006/main">
   <p:cSld>
     <p:spTree>
       <p:nvGrpSpPr>
@@ -3993,7 +5171,14 @@
         <p:cNvGrpSpPr/>
         <p:nvPr/>
       </p:nvGrpSpPr>
-      <p:grpSpPr/>
+      <p:grpSpPr>
+        <a:xfrm>
+          <a:off x="0" y="0"/>
+          <a:ext cx="0" cy="0"/>
+          <a:chOff x="0" y="0"/>
+          <a:chExt cx="0" cy="0"/>
+        </a:xfrm>
+      </p:grpSpPr>
       <p:pic>
         <p:nvPicPr>
           <p:cNvPr id="2" name="Picture 1" descr="slide_06.png"/>
@@ -4026,8 +5211,8 @@
 </p:sld>
 </file>
 
-<file path=ppt/slides/slide7.xml><?xml version="1.0" encoding="utf-8"?>
-<p:sld xmlns:a="http://schemas.openxmlformats.org/drawingml/2006/main" xmlns:p="http://schemas.openxmlformats.org/presentationml/2006/main" xmlns:r="http://schemas.openxmlformats.org/officeDocument/2006/relationships">
+<file path=ppt/slides/slide8.xml><?xml version="1.0" encoding="utf-8"?>
+<p:sld xmlns:a="http://schemas.openxmlformats.org/drawingml/2006/main" xmlns:r="http://schemas.openxmlformats.org/officeDocument/2006/relationships" xmlns:p="http://schemas.openxmlformats.org/presentationml/2006/main">
   <p:cSld>
     <p:spTree>
       <p:nvGrpSpPr>
@@ -4035,7 +5220,14 @@
         <p:cNvGrpSpPr/>
         <p:nvPr/>
       </p:nvGrpSpPr>
-      <p:grpSpPr/>
+      <p:grpSpPr>
+        <a:xfrm>
+          <a:off x="0" y="0"/>
+          <a:ext cx="0" cy="0"/>
+          <a:chOff x="0" y="0"/>
+          <a:chExt cx="0" cy="0"/>
+        </a:xfrm>
+      </p:grpSpPr>
       <p:pic>
         <p:nvPicPr>
           <p:cNvPr id="2" name="Picture 1" descr="slide_07.png"/>
@@ -4068,8 +5260,8 @@
 </p:sld>
 </file>
 
-<file path=ppt/slides/slide8.xml><?xml version="1.0" encoding="utf-8"?>
-<p:sld xmlns:a="http://schemas.openxmlformats.org/drawingml/2006/main" xmlns:p="http://schemas.openxmlformats.org/presentationml/2006/main" xmlns:r="http://schemas.openxmlformats.org/officeDocument/2006/relationships">
+<file path=ppt/slides/slide9.xml><?xml version="1.0" encoding="utf-8"?>
+<p:sld xmlns:a="http://schemas.openxmlformats.org/drawingml/2006/main" xmlns:r="http://schemas.openxmlformats.org/officeDocument/2006/relationships" xmlns:p="http://schemas.openxmlformats.org/presentationml/2006/main">
   <p:cSld>
     <p:spTree>
       <p:nvGrpSpPr>
@@ -4077,52 +5269,17 @@
         <p:cNvGrpSpPr/>
         <p:nvPr/>
       </p:nvGrpSpPr>
-      <p:grpSpPr/>
+      <p:grpSpPr>
+        <a:xfrm>
+          <a:off x="0" y="0"/>
+          <a:ext cx="0" cy="0"/>
+          <a:chOff x="0" y="0"/>
+          <a:chExt cx="0" cy="0"/>
+        </a:xfrm>
+      </p:grpSpPr>
       <p:pic>
         <p:nvPicPr>
           <p:cNvPr id="2" name="Picture 1" descr="slide_08.png"/>
-          <p:cNvPicPr>
-            <a:picLocks noChangeAspect="1"/>
-          </p:cNvPicPr>
-          <p:nvPr/>
-        </p:nvPicPr>
-        <p:blipFill>
-          <a:blip r:embed="rId2"/>
-          <a:stretch>
-            <a:fillRect/>
-          </a:stretch>
-        </p:blipFill>
-        <p:spPr>
-          <a:xfrm>
-            <a:off x="0" y="0"/>
-            <a:ext cx="12191695" cy="6858000"/>
-          </a:xfrm>
-          <a:prstGeom prst="rect">
-            <a:avLst/>
-          </a:prstGeom>
-        </p:spPr>
-      </p:pic>
-    </p:spTree>
-  </p:cSld>
-  <p:clrMapOvr>
-    <a:masterClrMapping/>
-  </p:clrMapOvr>
-</p:sld>
-</file>
-
-<file path=ppt/slides/slide9.xml><?xml version="1.0" encoding="utf-8"?>
-<p:sld xmlns:a="http://schemas.openxmlformats.org/drawingml/2006/main" xmlns:p="http://schemas.openxmlformats.org/presentationml/2006/main" xmlns:r="http://schemas.openxmlformats.org/officeDocument/2006/relationships">
-  <p:cSld>
-    <p:spTree>
-      <p:nvGrpSpPr>
-        <p:cNvPr id="1" name=""/>
-        <p:cNvGrpSpPr/>
-        <p:nvPr/>
-      </p:nvGrpSpPr>
-      <p:grpSpPr/>
-      <p:pic>
-        <p:nvPicPr>
-          <p:cNvPr id="2" name="Picture 1" descr="slide_09.png"/>
           <p:cNvPicPr>
             <a:picLocks noChangeAspect="1"/>
           </p:cNvPicPr>
@@ -4470,4 +5627,319 @@
   </a:objectDefaults>
   <a:extraClrSchemeLst/>
 </a:theme>
+</file>
+
+<file path=ppt/theme/theme2.xml><?xml version="1.0" encoding="utf-8"?>
+<a:theme xmlns:a="http://schemas.openxmlformats.org/drawingml/2006/main" name="Office Theme">
+  <a:themeElements>
+    <a:clrScheme name="Office">
+      <a:dk1>
+        <a:sysClr val="windowText" lastClr="000000"/>
+      </a:dk1>
+      <a:lt1>
+        <a:sysClr val="window" lastClr="FFFFFF"/>
+      </a:lt1>
+      <a:dk2>
+        <a:srgbClr val="0E2841"/>
+      </a:dk2>
+      <a:lt2>
+        <a:srgbClr val="E8E8E8"/>
+      </a:lt2>
+      <a:accent1>
+        <a:srgbClr val="156082"/>
+      </a:accent1>
+      <a:accent2>
+        <a:srgbClr val="E97132"/>
+      </a:accent2>
+      <a:accent3>
+        <a:srgbClr val="196B24"/>
+      </a:accent3>
+      <a:accent4>
+        <a:srgbClr val="0F9ED5"/>
+      </a:accent4>
+      <a:accent5>
+        <a:srgbClr val="A02B93"/>
+      </a:accent5>
+      <a:accent6>
+        <a:srgbClr val="4EA72E"/>
+      </a:accent6>
+      <a:hlink>
+        <a:srgbClr val="467886"/>
+      </a:hlink>
+      <a:folHlink>
+        <a:srgbClr val="96607D"/>
+      </a:folHlink>
+    </a:clrScheme>
+    <a:fontScheme name="Office">
+      <a:majorFont>
+        <a:latin typeface="Aptos Display" panose="02110004020202020204"/>
+        <a:ea typeface=""/>
+        <a:cs typeface=""/>
+        <a:font script="Jpan" typeface="游ゴシック Light"/>
+        <a:font script="Hang" typeface="맑은 고딕"/>
+        <a:font script="Hans" typeface="等线 Light"/>
+        <a:font script="Hant" typeface="新細明體"/>
+        <a:font script="Arab" typeface="Times New Roman"/>
+        <a:font script="Hebr" typeface="Times New Roman"/>
+        <a:font script="Thai" typeface="Angsana New"/>
+        <a:font script="Ethi" typeface="Nyala"/>
+        <a:font script="Beng" typeface="Vrinda"/>
+        <a:font script="Gujr" typeface="Shruti"/>
+        <a:font script="Khmr" typeface="MoolBoran"/>
+        <a:font script="Knda" typeface="Tunga"/>
+        <a:font script="Guru" typeface="Raavi"/>
+        <a:font script="Cans" typeface="Euphemia"/>
+        <a:font script="Cher" typeface="Plantagenet Cherokee"/>
+        <a:font script="Yiii" typeface="Microsoft Yi Baiti"/>
+        <a:font script="Tibt" typeface="Microsoft Himalaya"/>
+        <a:font script="Thaa" typeface="MV Boli"/>
+        <a:font script="Deva" typeface="Mangal"/>
+        <a:font script="Telu" typeface="Gautami"/>
+        <a:font script="Taml" typeface="Latha"/>
+        <a:font script="Syrc" typeface="Estrangelo Edessa"/>
+        <a:font script="Orya" typeface="Kalinga"/>
+        <a:font script="Mlym" typeface="Kartika"/>
+        <a:font script="Laoo" typeface="DokChampa"/>
+        <a:font script="Sinh" typeface="Iskoola Pota"/>
+        <a:font script="Mong" typeface="Mongolian Baiti"/>
+        <a:font script="Viet" typeface="Times New Roman"/>
+        <a:font script="Uigh" typeface="Microsoft Uighur"/>
+        <a:font script="Geor" typeface="Sylfaen"/>
+        <a:font script="Armn" typeface="Arial"/>
+        <a:font script="Bugi" typeface="Leelawadee UI"/>
+        <a:font script="Bopo" typeface="Microsoft JhengHei"/>
+        <a:font script="Java" typeface="Javanese Text"/>
+        <a:font script="Lisu" typeface="Segoe UI"/>
+        <a:font script="Mymr" typeface="Myanmar Text"/>
+        <a:font script="Nkoo" typeface="Ebrima"/>
+        <a:font script="Olck" typeface="Nirmala UI"/>
+        <a:font script="Osma" typeface="Ebrima"/>
+        <a:font script="Phag" typeface="Phagspa"/>
+        <a:font script="Syrn" typeface="Estrangelo Edessa"/>
+        <a:font script="Syrj" typeface="Estrangelo Edessa"/>
+        <a:font script="Syre" typeface="Estrangelo Edessa"/>
+        <a:font script="Sora" typeface="Nirmala UI"/>
+        <a:font script="Tale" typeface="Microsoft Tai Le"/>
+        <a:font script="Talu" typeface="Microsoft New Tai Lue"/>
+        <a:font script="Tfng" typeface="Ebrima"/>
+      </a:majorFont>
+      <a:minorFont>
+        <a:latin typeface="Aptos" panose="02110004020202020204"/>
+        <a:ea typeface=""/>
+        <a:cs typeface=""/>
+        <a:font script="Jpan" typeface="游ゴシック"/>
+        <a:font script="Hang" typeface="맑은 고딕"/>
+        <a:font script="Hans" typeface="等线"/>
+        <a:font script="Hant" typeface="新細明體"/>
+        <a:font script="Arab" typeface="Arial"/>
+        <a:font script="Hebr" typeface="Arial"/>
+        <a:font script="Thai" typeface="Cordia New"/>
+        <a:font script="Ethi" typeface="Nyala"/>
+        <a:font script="Beng" typeface="Vrinda"/>
+        <a:font script="Gujr" typeface="Shruti"/>
+        <a:font script="Khmr" typeface="DaunPenh"/>
+        <a:font script="Knda" typeface="Tunga"/>
+        <a:font script="Guru" typeface="Raavi"/>
+        <a:font script="Cans" typeface="Euphemia"/>
+        <a:font script="Cher" typeface="Plantagenet Cherokee"/>
+        <a:font script="Yiii" typeface="Microsoft Yi Baiti"/>
+        <a:font script="Tibt" typeface="Microsoft Himalaya"/>
+        <a:font script="Thaa" typeface="MV Boli"/>
+        <a:font script="Deva" typeface="Mangal"/>
+        <a:font script="Telu" typeface="Gautami"/>
+        <a:font script="Taml" typeface="Latha"/>
+        <a:font script="Syrc" typeface="Estrangelo Edessa"/>
+        <a:font script="Orya" typeface="Kalinga"/>
+        <a:font script="Mlym" typeface="Kartika"/>
+        <a:font script="Laoo" typeface="DokChampa"/>
+        <a:font script="Sinh" typeface="Iskoola Pota"/>
+        <a:font script="Mong" typeface="Mongolian Baiti"/>
+        <a:font script="Viet" typeface="Arial"/>
+        <a:font script="Uigh" typeface="Microsoft Uighur"/>
+        <a:font script="Geor" typeface="Sylfaen"/>
+        <a:font script="Armn" typeface="Arial"/>
+        <a:font script="Bugi" typeface="Leelawadee UI"/>
+        <a:font script="Bopo" typeface="Microsoft JhengHei"/>
+        <a:font script="Java" typeface="Javanese Text"/>
+        <a:font script="Lisu" typeface="Segoe UI"/>
+        <a:font script="Mymr" typeface="Myanmar Text"/>
+        <a:font script="Nkoo" typeface="Ebrima"/>
+        <a:font script="Olck" typeface="Nirmala UI"/>
+        <a:font script="Osma" typeface="Ebrima"/>
+        <a:font script="Phag" typeface="Phagspa"/>
+        <a:font script="Syrn" typeface="Estrangelo Edessa"/>
+        <a:font script="Syrj" typeface="Estrangelo Edessa"/>
+        <a:font script="Syre" typeface="Estrangelo Edessa"/>
+        <a:font script="Sora" typeface="Nirmala UI"/>
+        <a:font script="Tale" typeface="Microsoft Tai Le"/>
+        <a:font script="Talu" typeface="Microsoft New Tai Lue"/>
+        <a:font script="Tfng" typeface="Ebrima"/>
+      </a:minorFont>
+    </a:fontScheme>
+    <a:fmtScheme name="Office">
+      <a:fillStyleLst>
+        <a:solidFill>
+          <a:schemeClr val="phClr"/>
+        </a:solidFill>
+        <a:gradFill rotWithShape="1">
+          <a:gsLst>
+            <a:gs pos="0">
+              <a:schemeClr val="phClr">
+                <a:lumMod val="110000"/>
+                <a:satMod val="105000"/>
+                <a:tint val="67000"/>
+              </a:schemeClr>
+            </a:gs>
+            <a:gs pos="50000">
+              <a:schemeClr val="phClr">
+                <a:lumMod val="105000"/>
+                <a:satMod val="103000"/>
+                <a:tint val="73000"/>
+              </a:schemeClr>
+            </a:gs>
+            <a:gs pos="100000">
+              <a:schemeClr val="phClr">
+                <a:lumMod val="105000"/>
+                <a:satMod val="109000"/>
+                <a:tint val="81000"/>
+              </a:schemeClr>
+            </a:gs>
+          </a:gsLst>
+          <a:lin ang="5400000" scaled="0"/>
+        </a:gradFill>
+        <a:gradFill rotWithShape="1">
+          <a:gsLst>
+            <a:gs pos="0">
+              <a:schemeClr val="phClr">
+                <a:satMod val="103000"/>
+                <a:lumMod val="102000"/>
+                <a:tint val="94000"/>
+              </a:schemeClr>
+            </a:gs>
+            <a:gs pos="50000">
+              <a:schemeClr val="phClr">
+                <a:satMod val="110000"/>
+                <a:lumMod val="100000"/>
+                <a:shade val="100000"/>
+              </a:schemeClr>
+            </a:gs>
+            <a:gs pos="100000">
+              <a:schemeClr val="phClr">
+                <a:lumMod val="99000"/>
+                <a:satMod val="120000"/>
+                <a:shade val="78000"/>
+              </a:schemeClr>
+            </a:gs>
+          </a:gsLst>
+          <a:lin ang="5400000" scaled="0"/>
+        </a:gradFill>
+      </a:fillStyleLst>
+      <a:lnStyleLst>
+        <a:ln w="12700" cap="flat" cmpd="sng" algn="ctr">
+          <a:solidFill>
+            <a:schemeClr val="phClr"/>
+          </a:solidFill>
+          <a:prstDash val="solid"/>
+          <a:miter lim="800000"/>
+        </a:ln>
+        <a:ln w="19050" cap="flat" cmpd="sng" algn="ctr">
+          <a:solidFill>
+            <a:schemeClr val="phClr"/>
+          </a:solidFill>
+          <a:prstDash val="solid"/>
+          <a:miter lim="800000"/>
+        </a:ln>
+        <a:ln w="25400" cap="flat" cmpd="sng" algn="ctr">
+          <a:solidFill>
+            <a:schemeClr val="phClr"/>
+          </a:solidFill>
+          <a:prstDash val="solid"/>
+          <a:miter lim="800000"/>
+        </a:ln>
+      </a:lnStyleLst>
+      <a:effectStyleLst>
+        <a:effectStyle>
+          <a:effectLst/>
+        </a:effectStyle>
+        <a:effectStyle>
+          <a:effectLst/>
+        </a:effectStyle>
+        <a:effectStyle>
+          <a:effectLst>
+            <a:outerShdw blurRad="57150" dist="19050" dir="5400000" algn="ctr" rotWithShape="0">
+              <a:srgbClr val="000000">
+                <a:alpha val="63000"/>
+              </a:srgbClr>
+            </a:outerShdw>
+          </a:effectLst>
+        </a:effectStyle>
+      </a:effectStyleLst>
+      <a:bgFillStyleLst>
+        <a:solidFill>
+          <a:schemeClr val="phClr"/>
+        </a:solidFill>
+        <a:solidFill>
+          <a:schemeClr val="phClr">
+            <a:tint val="95000"/>
+            <a:satMod val="170000"/>
+          </a:schemeClr>
+        </a:solidFill>
+        <a:gradFill rotWithShape="1">
+          <a:gsLst>
+            <a:gs pos="0">
+              <a:schemeClr val="phClr">
+                <a:tint val="93000"/>
+                <a:satMod val="150000"/>
+                <a:shade val="98000"/>
+                <a:lumMod val="102000"/>
+              </a:schemeClr>
+            </a:gs>
+            <a:gs pos="50000">
+              <a:schemeClr val="phClr">
+                <a:tint val="98000"/>
+                <a:satMod val="130000"/>
+                <a:shade val="90000"/>
+                <a:lumMod val="103000"/>
+              </a:schemeClr>
+            </a:gs>
+            <a:gs pos="100000">
+              <a:schemeClr val="phClr">
+                <a:shade val="63000"/>
+                <a:satMod val="120000"/>
+              </a:schemeClr>
+            </a:gs>
+          </a:gsLst>
+          <a:lin ang="5400000" scaled="0"/>
+        </a:gradFill>
+      </a:bgFillStyleLst>
+    </a:fmtScheme>
+  </a:themeElements>
+  <a:objectDefaults>
+    <a:lnDef>
+      <a:spPr/>
+      <a:bodyPr/>
+      <a:lstStyle/>
+      <a:style>
+        <a:lnRef idx="2">
+          <a:schemeClr val="accent1"/>
+        </a:lnRef>
+        <a:fillRef idx="0">
+          <a:schemeClr val="accent1"/>
+        </a:fillRef>
+        <a:effectRef idx="1">
+          <a:schemeClr val="accent1"/>
+        </a:effectRef>
+        <a:fontRef idx="minor">
+          <a:schemeClr val="tx1"/>
+        </a:fontRef>
+      </a:style>
+    </a:lnDef>
+  </a:objectDefaults>
+  <a:extraClrSchemeLst/>
+  <a:extLst>
+    <a:ext uri="{05A4C25C-085E-4340-85A3-A5531E510DB2}">
+      <thm15:themeFamily xmlns:thm15="http://schemas.microsoft.com/office/thememl/2012/main" name="Office Theme" id="{2E142A2C-CD16-42D6-873A-C26D2A0506FA}" vid="{1BDDFF52-6CD6-40A5-AB3C-68EB2F1E4D0A}"/>
+    </a:ext>
+  </a:extLst>
+</a:theme>
 </file>
</xml_diff>